<commit_message>
Improve KOM PN 2027: executive summary, monthly disbursement chart, workbook summary sheet
Co-Authored-By: Claude Sonnet 5.5 <noreply@anthropic.com>
Claude-Session: https://claude.ai/code/session_01DkQp5MPyRPWnP5DLQm3nzM
</commit_message>
<xml_diff>
--- a/PN_2027/KOM_PN_2027_Obras_DCMD_RL_RT.pptx
+++ b/PN_2027/KOM_PN_2027_Obras_DCMD_RL_RT.pptx
@@ -14,8 +14,10 @@
   <p:sldIdLst>
     <p:sldId id="257" r:id="rId6"/>
     <p:sldId id="266" r:id="rId7"/>
+    <p:sldId id="281" r:id="rId33"/>
     <p:sldId id="274" r:id="rId26"/>
     <p:sldId id="273" r:id="rId10"/>
+    <p:sldId id="282" r:id="rId34"/>
     <p:sldId id="269" r:id="rId11"/>
     <p:sldId id="270" r:id="rId13"/>
     <p:sldId id="275" r:id="rId27"/>
@@ -673,6 +675,233 @@
 </pc:chgInfo>
 </file>
 
+<file path=ppt/charts/chart1.xml><?xml version="1.0" encoding="utf-8"?>
+<c:chartSpace xmlns:c="http://schemas.openxmlformats.org/drawingml/2006/chart" xmlns:a="http://schemas.openxmlformats.org/drawingml/2006/main" xmlns:r="http://schemas.openxmlformats.org/officeDocument/2006/relationships">
+  <c:date1904 val="0"/>
+  <c:chart>
+    <c:title>
+      <c:tx>
+        <c:rich>
+          <a:bodyPr/>
+          <a:lstStyle/>
+          <a:p>
+            <a:r>
+              <a:rPr sz="1200"/>
+              <a:t>Desembolso mensal (R$ mil)</a:t>
+            </a:r>
+          </a:p>
+        </c:rich>
+      </c:tx>
+      <c:layout/>
+      <c:overlay val="0"/>
+    </c:title>
+    <c:autoTitleDeleted val="0"/>
+    <c:plotArea>
+      <c:barChart>
+        <c:barDir val="col"/>
+        <c:grouping val="clustered"/>
+        <c:ser>
+          <c:idx val="0"/>
+          <c:order val="0"/>
+          <c:tx>
+            <c:strRef>
+              <c:f>Sheet1!$B$1</c:f>
+              <c:strCache>
+                <c:ptCount val="1"/>
+                <c:pt idx="0">
+                  <c:v>Desembolso mensal (R$ mil)</c:v>
+                </c:pt>
+              </c:strCache>
+            </c:strRef>
+          </c:tx>
+          <c:spPr>
+            <a:solidFill>
+              <a:srgbClr val="F47B20"/>
+            </a:solidFill>
+          </c:spPr>
+          <c:cat>
+            <c:strRef>
+              <c:f>Sheet1!$A$2:$A$13</c:f>
+              <c:strCache>
+                <c:ptCount val="12"/>
+                <c:pt idx="0">
+                  <c:v>Jan</c:v>
+                </c:pt>
+                <c:pt idx="1">
+                  <c:v>Fev</c:v>
+                </c:pt>
+                <c:pt idx="2">
+                  <c:v>Mar</c:v>
+                </c:pt>
+                <c:pt idx="3">
+                  <c:v>Abr</c:v>
+                </c:pt>
+                <c:pt idx="4">
+                  <c:v>Mai</c:v>
+                </c:pt>
+                <c:pt idx="5">
+                  <c:v>Jun</c:v>
+                </c:pt>
+                <c:pt idx="6">
+                  <c:v>Jul</c:v>
+                </c:pt>
+                <c:pt idx="7">
+                  <c:v>Ago</c:v>
+                </c:pt>
+                <c:pt idx="8">
+                  <c:v>Set</c:v>
+                </c:pt>
+                <c:pt idx="9">
+                  <c:v>Out</c:v>
+                </c:pt>
+                <c:pt idx="10">
+                  <c:v>Nov</c:v>
+                </c:pt>
+                <c:pt idx="11">
+                  <c:v>Dez</c:v>
+                </c:pt>
+              </c:strCache>
+            </c:strRef>
+          </c:cat>
+          <c:val>
+            <c:numRef>
+              <c:f>Sheet1!$B$2:$B$13</c:f>
+              <c:numCache>
+                <c:formatCode>General</c:formatCode>
+                <c:ptCount val="12"/>
+                <c:pt idx="0">
+                  <c:v>429</c:v>
+                </c:pt>
+                <c:pt idx="1">
+                  <c:v>429</c:v>
+                </c:pt>
+                <c:pt idx="2">
+                  <c:v>429</c:v>
+                </c:pt>
+                <c:pt idx="3">
+                  <c:v>429</c:v>
+                </c:pt>
+                <c:pt idx="4">
+                  <c:v>449</c:v>
+                </c:pt>
+                <c:pt idx="5">
+                  <c:v>449</c:v>
+                </c:pt>
+                <c:pt idx="6">
+                  <c:v>449</c:v>
+                </c:pt>
+                <c:pt idx="7">
+                  <c:v>449</c:v>
+                </c:pt>
+                <c:pt idx="8">
+                  <c:v>429</c:v>
+                </c:pt>
+                <c:pt idx="9">
+                  <c:v>429</c:v>
+                </c:pt>
+                <c:pt idx="10">
+                  <c:v>429</c:v>
+                </c:pt>
+                <c:pt idx="11">
+                  <c:v>429</c:v>
+                </c:pt>
+              </c:numCache>
+            </c:numRef>
+          </c:val>
+        </c:ser>
+        <c:dLbls>
+          <c:numFmt formatCode="#,##0" sourceLinked="0"/>
+          <c:txPr>
+            <a:bodyPr/>
+            <a:lstStyle/>
+            <a:p>
+              <a:pPr>
+                <a:defRPr sz="1000">
+                  <a:latin typeface="DM Sans"/>
+                </a:defRPr>
+              </a:pPr>
+            </a:p>
+          </c:txPr>
+          <c:dLblPos val="outEnd"/>
+          <c:showLegendKey val="0"/>
+          <c:showVal val="1"/>
+          <c:showCatName val="0"/>
+          <c:showSerName val="0"/>
+          <c:showPercent val="0"/>
+          <c:showBubbleSize val="0"/>
+          <c:showLeaderLines val="1"/>
+        </c:dLbls>
+        <c:gapWidth val="60"/>
+        <c:axId val="-2068027336"/>
+        <c:axId val="-2113994440"/>
+      </c:barChart>
+      <c:catAx>
+        <c:axId val="-2068027336"/>
+        <c:scaling>
+          <c:orientation val="minMax"/>
+        </c:scaling>
+        <c:delete val="0"/>
+        <c:axPos val="b"/>
+        <c:majorTickMark val="out"/>
+        <c:minorTickMark val="none"/>
+        <c:tickLblPos val="nextTo"/>
+        <c:txPr>
+          <a:bodyPr/>
+          <a:lstStyle/>
+          <a:p>
+            <a:pPr>
+              <a:defRPr sz="1000"/>
+            </a:pPr>
+          </a:p>
+        </c:txPr>
+        <c:crossAx val="-2113994440"/>
+        <c:crosses val="autoZero"/>
+        <c:auto val="1"/>
+        <c:lblAlgn val="ctr"/>
+        <c:lblOffset val="100"/>
+        <c:noMultiLvlLbl val="0"/>
+      </c:catAx>
+      <c:valAx>
+        <c:axId val="-2113994440"/>
+        <c:scaling>
+          <c:min val="0.0"/>
+        </c:scaling>
+        <c:delete val="0"/>
+        <c:axPos val="l"/>
+        <c:majorTickMark val="out"/>
+        <c:minorTickMark val="none"/>
+        <c:tickLblPos val="nextTo"/>
+        <c:txPr>
+          <a:bodyPr/>
+          <a:lstStyle/>
+          <a:p>
+            <a:pPr>
+              <a:defRPr sz="900"/>
+            </a:pPr>
+          </a:p>
+        </c:txPr>
+        <c:crossAx val="-2068027336"/>
+        <c:crosses val="autoZero"/>
+      </c:valAx>
+    </c:plotArea>
+    <c:dispBlanksAs val="gap"/>
+  </c:chart>
+  <c:txPr>
+    <a:bodyPr/>
+    <a:lstStyle/>
+    <a:p>
+      <a:pPr>
+        <a:defRPr sz="1800"/>
+      </a:pPr>
+      <a:endParaRPr lang="en-US"/>
+    </a:p>
+  </c:txPr>
+  <c:externalData r:id="rId1">
+    <c:autoUpdate val="0"/>
+  </c:externalData>
+</c:chartSpace>
+</file>
+
 <file path=ppt/handoutMasters/handoutMaster1.xml><?xml version="1.0" encoding="utf-8"?>
 <p:handoutMaster xmlns:a="http://schemas.openxmlformats.org/drawingml/2006/main" xmlns:r="http://schemas.openxmlformats.org/officeDocument/2006/relationships" xmlns:p="http://schemas.openxmlformats.org/presentationml/2006/main">
   <p:cSld>
@@ -4874,7 +5103,7 @@
                 </a:solidFill>
                 <a:latin typeface="DM Sans"/>
               </a:rPr>
-              <a:t>03  ·  OBRAS DCMD – RL / RT  ·  PN 2027</a:t>
+              <a:t>04  ·  OBRAS DCMD – RL / RT  ·  PN 2027</a:t>
             </a:r>
             <a:r>
               <a:rPr lang="pt-BR" sz="1000" b="1">
@@ -7401,7 +7630,7 @@
                 </a:solidFill>
                 <a:latin typeface="DM Sans"/>
               </a:rPr>
-              <a:t>07  ·  OBRAS DCMD – RL / RT  ·  PN 2027</a:t>
+              <a:t>09  ·  OBRAS DCMD – RL / RT  ·  PN 2027</a:t>
             </a:r>
             <a:r>
               <a:rPr lang="pt-BR" sz="1000" b="1">
@@ -8800,7 +9029,7 @@
                 </a:solidFill>
                 <a:latin typeface="DM Sans"/>
               </a:rPr>
-              <a:t>09  ·  OBRAS DCMD – RL / RT  ·  PN 2027</a:t>
+              <a:t>11  ·  OBRAS DCMD – RL / RT  ·  PN 2027</a:t>
             </a:r>
             <a:r>
               <a:rPr lang="pt-BR" sz="1000" b="1">
@@ -10732,7 +10961,7 @@
                 </a:solidFill>
                 <a:latin typeface="DM Sans"/>
               </a:rPr>
-              <a:t>10  ·  OBRAS DCMD – RL / RT  ·  PN 2027</a:t>
+              <a:t>12  ·  OBRAS DCMD – RL / RT  ·  PN 2027</a:t>
             </a:r>
             <a:r>
               <a:rPr lang="pt-BR" sz="1000" b="1">
@@ -14279,7 +14508,7 @@
                 </a:solidFill>
                 <a:latin typeface="DM Sans"/>
               </a:rPr>
-              <a:t>11  ·  OBRAS DCMD – RL / RT  ·  PN 2027</a:t>
+              <a:t>13  ·  OBRAS DCMD – RL / RT  ·  PN 2027</a:t>
             </a:r>
             <a:r>
               <a:rPr lang="pt-BR" sz="1000" b="1">
@@ -17826,7 +18055,7 @@
                 </a:solidFill>
                 <a:latin typeface="DM Sans"/>
               </a:rPr>
-              <a:t>12  ·  OBRAS DCMD – RL / RT  ·  PN 2027</a:t>
+              <a:t>14  ·  OBRAS DCMD – RL / RT  ·  PN 2027</a:t>
             </a:r>
             <a:r>
               <a:rPr lang="pt-BR" sz="1000" b="1">
@@ -21373,7 +21602,7 @@
                 </a:solidFill>
                 <a:latin typeface="DM Sans"/>
               </a:rPr>
-              <a:t>13  ·  OBRAS DCMD – RL / RT  ·  PN 2027</a:t>
+              <a:t>15  ·  OBRAS DCMD – RL / RT  ·  PN 2027</a:t>
             </a:r>
             <a:r>
               <a:rPr lang="pt-BR" sz="1000" b="1">
@@ -26632,6 +26861,2485 @@
         <p14:creationId xmlns:p14="http://schemas.microsoft.com/office/powerpoint/2010/main" val="1796060300"/>
       </p:ext>
     </p:extLst>
+  </p:cSld>
+  <p:clrMapOvr>
+    <a:masterClrMapping/>
+  </p:clrMapOvr>
+</p:sld>
+</file>
+
+<file path=ppt/slides/slide20.xml><?xml version="1.0" encoding="utf-8"?>
+<p:sld xmlns:a="http://schemas.openxmlformats.org/drawingml/2006/main" xmlns:p="http://schemas.openxmlformats.org/presentationml/2006/main" xmlns:r="http://schemas.openxmlformats.org/officeDocument/2006/relationships">
+  <p:cSld>
+    <p:spTree>
+      <p:nvGrpSpPr>
+        <p:cNvPr id="1" name=""/>
+        <p:cNvGrpSpPr/>
+        <p:nvPr/>
+      </p:nvGrpSpPr>
+      <p:grpSpPr/>
+      <p:sp>
+        <p:nvSpPr>
+          <p:cNvPr id="6" name="Title 2">
+            <a:extLst>
+              <a:ext uri="{FF2B5EF4-FFF2-40B4-BE49-F238E27FC236}">
+                <a16:creationId xmlns:a16="http://schemas.microsoft.com/office/drawing/2014/main" id="{BBAC4CB0-69CB-452A-4A56-4E4A151CF2C1}"/>
+              </a:ext>
+            </a:extLst>
+          </p:cNvPr>
+          <p:cNvSpPr txBox="1">
+            <a:spLocks/>
+          </p:cNvSpPr>
+          <p:nvPr/>
+        </p:nvSpPr>
+        <p:spPr>
+          <a:xfrm>
+            <a:off x="457200" y="566928"/>
+            <a:ext cx="7790688" cy="566928"/>
+          </a:xfrm>
+          <a:prstGeom prst="rect">
+            <a:avLst/>
+          </a:prstGeom>
+        </p:spPr>
+        <p:txBody>
+          <a:bodyPr lIns="0" tIns="0" rIns="0" bIns="0" anchor="ctr"/>
+          <a:lstStyle>
+            <a:lvl1pPr algn="l" defTabSz="914400" rtl="0" eaLnBrk="1" latinLnBrk="0" hangingPunct="1">
+              <a:lnSpc>
+                <a:spcPct val="90000"/>
+              </a:lnSpc>
+              <a:spcBef>
+                <a:spcPct val="0"/>
+              </a:spcBef>
+              <a:buNone/>
+              <a:defRPr sz="4400" kern="1200">
+                <a:solidFill>
+                  <a:schemeClr val="tx1"/>
+                </a:solidFill>
+                <a:latin typeface="+mj-lt"/>
+                <a:ea typeface="+mj-ea"/>
+                <a:cs typeface="+mj-cs"/>
+              </a:defRPr>
+            </a:lvl1pPr>
+          </a:lstStyle>
+          <a:p>
+            <a:r>
+              <a:rPr lang="pt-BR" sz="3000" b="1">
+                <a:solidFill>
+                  <a:srgbClr val="1F1F4C"/>
+                </a:solidFill>
+                <a:latin typeface="DM Sans"/>
+              </a:rPr>
+              <a:t>Resumo Executivo</a:t>
+            </a:r>
+          </a:p>
+        </p:txBody>
+      </p:sp>
+      <p:sp>
+        <p:nvSpPr>
+          <p:cNvPr id="7" name="Eyebrow">
+            <a:extLst>
+              <a:ext uri="{FF2B5EF4-FFF2-40B4-BE49-F238E27FC236}">
+                <a16:creationId xmlns:a16="http://schemas.microsoft.com/office/drawing/2014/main" id="{50824C48-A21F-0B29-3A2A-0036E3CE3299}"/>
+              </a:ext>
+            </a:extLst>
+          </p:cNvPr>
+          <p:cNvSpPr txBox="1"/>
+          <p:nvPr/>
+        </p:nvSpPr>
+        <p:spPr>
+          <a:xfrm>
+            <a:off x="457200" y="347472"/>
+            <a:ext cx="7315200" cy="169277"/>
+          </a:xfrm>
+          <a:prstGeom prst="rect">
+            <a:avLst/>
+          </a:prstGeom>
+          <a:noFill/>
+        </p:spPr>
+        <p:txBody>
+          <a:bodyPr wrap="square" lIns="0" tIns="0" rIns="0" bIns="0" anchor="t">
+            <a:spAutoFit/>
+          </a:bodyPr>
+          <a:lstStyle/>
+          <a:p>
+            <a:pPr algn="l"/>
+            <a:r>
+              <a:rPr sz="1100" b="1" i="0" spc="150">
+                <a:solidFill>
+                  <a:srgbClr val="F47B20"/>
+                </a:solidFill>
+                <a:latin typeface="DM Sans"/>
+              </a:rPr>
+              <a:t>KICKOFF MEETING</a:t>
+            </a:r>
+            <a:r>
+              <a:rPr sz="1100" b="1" i="0" spc="150">
+                <a:solidFill>
+                  <a:srgbClr val="989898"/>
+                </a:solidFill>
+                <a:latin typeface="DM Sans"/>
+              </a:rPr>
+              <a:t>   |   PN 2027  ·  OBRAS DCMD – RL / RT</a:t>
+            </a:r>
+            <a:r>
+              <a:rPr lang="pt-BR" sz="1100" b="1" i="0" spc="150">
+                <a:solidFill>
+                  <a:srgbClr val="989898"/>
+                </a:solidFill>
+                <a:latin typeface="DM Sans"/>
+              </a:rPr>
+              <a:t/>
+            </a:r>
+            <a:endParaRPr sz="1100" b="1" i="0" spc="150">
+              <a:solidFill>
+                <a:srgbClr val="989898"/>
+              </a:solidFill>
+              <a:latin typeface="DM Sans"/>
+            </a:endParaRPr>
+          </a:p>
+        </p:txBody>
+      </p:sp>
+      <p:sp>
+        <p:nvSpPr>
+          <p:cNvPr id="8" name="Rodapé">
+            <a:extLst>
+              <a:ext uri="{FF2B5EF4-FFF2-40B4-BE49-F238E27FC236}">
+                <a16:creationId xmlns:a16="http://schemas.microsoft.com/office/drawing/2014/main" id="{8F7B4335-BE0B-DF62-CED3-FA23D73E207F}"/>
+              </a:ext>
+            </a:extLst>
+          </p:cNvPr>
+          <p:cNvSpPr txBox="1"/>
+          <p:nvPr/>
+        </p:nvSpPr>
+        <p:spPr>
+          <a:xfrm>
+            <a:off x="457200" y="6428232"/>
+            <a:ext cx="7315200" cy="153888"/>
+          </a:xfrm>
+          <a:prstGeom prst="rect">
+            <a:avLst/>
+          </a:prstGeom>
+          <a:noFill/>
+        </p:spPr>
+        <p:txBody>
+          <a:bodyPr wrap="square" lIns="0" tIns="0" rIns="0" bIns="0" anchor="t">
+            <a:spAutoFit/>
+          </a:bodyPr>
+          <a:lstStyle/>
+          <a:p>
+            <a:pPr algn="l"/>
+            <a:r>
+              <a:rPr sz="1000" b="1" i="0">
+                <a:solidFill>
+                  <a:srgbClr val="1F1F4C"/>
+                </a:solidFill>
+                <a:latin typeface="DM Sans"/>
+              </a:rPr>
+              <a:t>03  ·  OBRAS DCMD – RL / RT  ·  PN 2027</a:t>
+            </a:r>
+            <a:r>
+              <a:rPr lang="pt-BR" sz="1000" b="1">
+                <a:solidFill>
+                  <a:srgbClr val="1F1F4C"/>
+                </a:solidFill>
+                <a:latin typeface="DM Sans"/>
+              </a:rPr>
+              <a:t/>
+            </a:r>
+            <a:r>
+              <a:rPr sz="900" b="0" i="0">
+                <a:solidFill>
+                  <a:srgbClr val="989898"/>
+                </a:solidFill>
+                <a:latin typeface="DM Sans"/>
+              </a:rPr>
+              <a:t/>
+            </a:r>
+            <a:r>
+              <a:rPr lang="pt-BR" sz="900" b="0" i="0">
+                <a:solidFill>
+                  <a:srgbClr val="989898"/>
+                </a:solidFill>
+                <a:latin typeface="DM Sans"/>
+              </a:rPr>
+              <a:t/>
+            </a:r>
+            <a:endParaRPr sz="900" b="0" i="0">
+              <a:solidFill>
+                <a:srgbClr val="989898"/>
+              </a:solidFill>
+              <a:latin typeface="DM Sans"/>
+            </a:endParaRPr>
+          </a:p>
+        </p:txBody>
+      </p:sp>
+      <p:sp>
+        <p:nvSpPr>
+          <p:cNvPr id="9" name="Rounded Rectangle 8"/>
+          <p:cNvSpPr/>
+          <p:nvPr/>
+        </p:nvSpPr>
+        <p:spPr>
+          <a:xfrm>
+            <a:off x="457200" y="1350000"/>
+            <a:ext cx="2700000" cy="1000000"/>
+          </a:xfrm>
+          <a:prstGeom prst="roundRect">
+            <a:avLst/>
+          </a:prstGeom>
+          <a:solidFill>
+            <a:srgbClr val="1F1F4C"/>
+          </a:solidFill>
+          <a:ln>
+            <a:noFill/>
+          </a:ln>
+          <a:effectLst/>
+        </p:spPr>
+        <p:style>
+          <a:lnRef idx="1">
+            <a:schemeClr val="accent1"/>
+          </a:lnRef>
+          <a:fillRef idx="3">
+            <a:schemeClr val="accent1"/>
+          </a:fillRef>
+          <a:effectRef idx="2">
+            <a:schemeClr val="accent1"/>
+          </a:effectRef>
+          <a:fontRef idx="minor">
+            <a:schemeClr val="lt1"/>
+          </a:fontRef>
+        </p:style>
+        <p:txBody>
+          <a:bodyPr rtlCol="0" anchor="ctr"/>
+          <a:lstStyle/>
+          <a:p>
+            <a:pPr algn="ctr"/>
+          </a:p>
+        </p:txBody>
+      </p:sp>
+      <p:sp>
+        <p:nvSpPr>
+          <p:cNvPr id="10" name="TextBox 9"/>
+          <p:cNvSpPr txBox="1"/>
+          <p:nvPr/>
+        </p:nvSpPr>
+        <p:spPr>
+          <a:xfrm>
+            <a:off x="457200" y="1400000"/>
+            <a:ext cx="2700000" cy="550000"/>
+          </a:xfrm>
+          <a:prstGeom prst="rect">
+            <a:avLst/>
+          </a:prstGeom>
+          <a:noFill/>
+        </p:spPr>
+        <p:txBody>
+          <a:bodyPr wrap="square" lIns="36000" rIns="36000" tIns="0" bIns="0" anchor="ctr">
+            <a:spAutoFit/>
+          </a:bodyPr>
+          <a:lstStyle/>
+          <a:p>
+            <a:pPr algn="ctr"/>
+            <a:r>
+              <a:rPr sz="2200" b="1" i="0">
+                <a:solidFill>
+                  <a:srgbClr val="FFFFFF"/>
+                </a:solidFill>
+                <a:latin typeface="DM Sans"/>
+              </a:rPr>
+              <a:t>13</a:t>
+            </a:r>
+          </a:p>
+        </p:txBody>
+      </p:sp>
+      <p:sp>
+        <p:nvSpPr>
+          <p:cNvPr id="11" name="TextBox 10"/>
+          <p:cNvSpPr txBox="1"/>
+          <p:nvPr/>
+        </p:nvSpPr>
+        <p:spPr>
+          <a:xfrm>
+            <a:off x="457200" y="1950000"/>
+            <a:ext cx="2700000" cy="300000"/>
+          </a:xfrm>
+          <a:prstGeom prst="rect">
+            <a:avLst/>
+          </a:prstGeom>
+          <a:noFill/>
+        </p:spPr>
+        <p:txBody>
+          <a:bodyPr wrap="square" lIns="36000" rIns="36000" tIns="0" bIns="0" anchor="ctr">
+            <a:spAutoFit/>
+          </a:bodyPr>
+          <a:lstStyle/>
+          <a:p>
+            <a:pPr algn="ctr"/>
+            <a:r>
+              <a:rPr sz="1000" b="0" i="0">
+                <a:solidFill>
+                  <a:srgbClr val="B5E622"/>
+                </a:solidFill>
+                <a:latin typeface="DM Sans"/>
+              </a:rPr>
+              <a:t>blocos de instalação</a:t>
+            </a:r>
+          </a:p>
+        </p:txBody>
+      </p:sp>
+      <p:sp>
+        <p:nvSpPr>
+          <p:cNvPr id="12" name="Rounded Rectangle 11"/>
+          <p:cNvSpPr/>
+          <p:nvPr/>
+        </p:nvSpPr>
+        <p:spPr>
+          <a:xfrm>
+            <a:off x="3307200" y="1350000"/>
+            <a:ext cx="2700000" cy="1000000"/>
+          </a:xfrm>
+          <a:prstGeom prst="roundRect">
+            <a:avLst/>
+          </a:prstGeom>
+          <a:solidFill>
+            <a:srgbClr val="1F1F4C"/>
+          </a:solidFill>
+          <a:ln>
+            <a:noFill/>
+          </a:ln>
+          <a:effectLst/>
+        </p:spPr>
+        <p:style>
+          <a:lnRef idx="1">
+            <a:schemeClr val="accent1"/>
+          </a:lnRef>
+          <a:fillRef idx="3">
+            <a:schemeClr val="accent1"/>
+          </a:fillRef>
+          <a:effectRef idx="2">
+            <a:schemeClr val="accent1"/>
+          </a:effectRef>
+          <a:fontRef idx="minor">
+            <a:schemeClr val="lt1"/>
+          </a:fontRef>
+        </p:style>
+        <p:txBody>
+          <a:bodyPr rtlCol="0" anchor="ctr"/>
+          <a:lstStyle/>
+          <a:p>
+            <a:pPr algn="ctr"/>
+          </a:p>
+        </p:txBody>
+      </p:sp>
+      <p:sp>
+        <p:nvSpPr>
+          <p:cNvPr id="13" name="TextBox 12"/>
+          <p:cNvSpPr txBox="1"/>
+          <p:nvPr/>
+        </p:nvSpPr>
+        <p:spPr>
+          <a:xfrm>
+            <a:off x="3307200" y="1400000"/>
+            <a:ext cx="2700000" cy="550000"/>
+          </a:xfrm>
+          <a:prstGeom prst="rect">
+            <a:avLst/>
+          </a:prstGeom>
+          <a:noFill/>
+        </p:spPr>
+        <p:txBody>
+          <a:bodyPr wrap="square" lIns="36000" rIns="36000" tIns="0" bIns="0" anchor="ctr">
+            <a:spAutoFit/>
+          </a:bodyPr>
+          <a:lstStyle/>
+          <a:p>
+            <a:pPr algn="ctr"/>
+            <a:r>
+              <a:rPr sz="2200" b="1" i="0">
+                <a:solidFill>
+                  <a:srgbClr val="FFFFFF"/>
+                </a:solidFill>
+                <a:latin typeface="DM Sans"/>
+              </a:rPr>
+              <a:t>21</a:t>
+            </a:r>
+          </a:p>
+        </p:txBody>
+      </p:sp>
+      <p:sp>
+        <p:nvSpPr>
+          <p:cNvPr id="14" name="TextBox 13"/>
+          <p:cNvSpPr txBox="1"/>
+          <p:nvPr/>
+        </p:nvSpPr>
+        <p:spPr>
+          <a:xfrm>
+            <a:off x="3307200" y="1950000"/>
+            <a:ext cx="2700000" cy="300000"/>
+          </a:xfrm>
+          <a:prstGeom prst="rect">
+            <a:avLst/>
+          </a:prstGeom>
+          <a:noFill/>
+        </p:spPr>
+        <p:txBody>
+          <a:bodyPr wrap="square" lIns="36000" rIns="36000" tIns="0" bIns="0" anchor="ctr">
+            <a:spAutoFit/>
+          </a:bodyPr>
+          <a:lstStyle/>
+          <a:p>
+            <a:pPr algn="ctr"/>
+            <a:r>
+              <a:rPr sz="1000" b="0" i="0">
+                <a:solidFill>
+                  <a:srgbClr val="B5E622"/>
+                </a:solidFill>
+                <a:latin typeface="DM Sans"/>
+              </a:rPr>
+              <a:t>RL + RT (+3 TripSaver)</a:t>
+            </a:r>
+          </a:p>
+        </p:txBody>
+      </p:sp>
+      <p:sp>
+        <p:nvSpPr>
+          <p:cNvPr id="15" name="Rounded Rectangle 14"/>
+          <p:cNvSpPr/>
+          <p:nvPr/>
+        </p:nvSpPr>
+        <p:spPr>
+          <a:xfrm>
+            <a:off x="6157200" y="1350000"/>
+            <a:ext cx="2700000" cy="1000000"/>
+          </a:xfrm>
+          <a:prstGeom prst="roundRect">
+            <a:avLst/>
+          </a:prstGeom>
+          <a:solidFill>
+            <a:srgbClr val="1F1F4C"/>
+          </a:solidFill>
+          <a:ln>
+            <a:noFill/>
+          </a:ln>
+          <a:effectLst/>
+        </p:spPr>
+        <p:style>
+          <a:lnRef idx="1">
+            <a:schemeClr val="accent1"/>
+          </a:lnRef>
+          <a:fillRef idx="3">
+            <a:schemeClr val="accent1"/>
+          </a:fillRef>
+          <a:effectRef idx="2">
+            <a:schemeClr val="accent1"/>
+          </a:effectRef>
+          <a:fontRef idx="minor">
+            <a:schemeClr val="lt1"/>
+          </a:fontRef>
+        </p:style>
+        <p:txBody>
+          <a:bodyPr rtlCol="0" anchor="ctr"/>
+          <a:lstStyle/>
+          <a:p>
+            <a:pPr algn="ctr"/>
+          </a:p>
+        </p:txBody>
+      </p:sp>
+      <p:sp>
+        <p:nvSpPr>
+          <p:cNvPr id="16" name="TextBox 15"/>
+          <p:cNvSpPr txBox="1"/>
+          <p:nvPr/>
+        </p:nvSpPr>
+        <p:spPr>
+          <a:xfrm>
+            <a:off x="6157200" y="1400000"/>
+            <a:ext cx="2700000" cy="550000"/>
+          </a:xfrm>
+          <a:prstGeom prst="rect">
+            <a:avLst/>
+          </a:prstGeom>
+          <a:noFill/>
+        </p:spPr>
+        <p:txBody>
+          <a:bodyPr wrap="square" lIns="36000" rIns="36000" tIns="0" bIns="0" anchor="ctr">
+            <a:spAutoFit/>
+          </a:bodyPr>
+          <a:lstStyle/>
+          <a:p>
+            <a:pPr algn="ctr"/>
+            <a:r>
+              <a:rPr sz="2200" b="1" i="0">
+                <a:solidFill>
+                  <a:srgbClr val="FFFFFF"/>
+                </a:solidFill>
+                <a:latin typeface="DM Sans"/>
+              </a:rPr>
+              <a:t>R$ 5,23 mi</a:t>
+            </a:r>
+          </a:p>
+        </p:txBody>
+      </p:sp>
+      <p:sp>
+        <p:nvSpPr>
+          <p:cNvPr id="17" name="TextBox 16"/>
+          <p:cNvSpPr txBox="1"/>
+          <p:nvPr/>
+        </p:nvSpPr>
+        <p:spPr>
+          <a:xfrm>
+            <a:off x="6157200" y="1950000"/>
+            <a:ext cx="2700000" cy="300000"/>
+          </a:xfrm>
+          <a:prstGeom prst="rect">
+            <a:avLst/>
+          </a:prstGeom>
+          <a:noFill/>
+        </p:spPr>
+        <p:txBody>
+          <a:bodyPr wrap="square" lIns="36000" rIns="36000" tIns="0" bIns="0" anchor="ctr">
+            <a:spAutoFit/>
+          </a:bodyPr>
+          <a:lstStyle/>
+          <a:p>
+            <a:pPr algn="ctr"/>
+            <a:r>
+              <a:rPr sz="1000" b="0" i="0">
+                <a:solidFill>
+                  <a:srgbClr val="B5E622"/>
+                </a:solidFill>
+                <a:latin typeface="DM Sans"/>
+              </a:rPr>
+              <a:t>orçamento 2027</a:t>
+            </a:r>
+          </a:p>
+        </p:txBody>
+      </p:sp>
+      <p:sp>
+        <p:nvSpPr>
+          <p:cNvPr id="18" name="Rounded Rectangle 17"/>
+          <p:cNvSpPr/>
+          <p:nvPr/>
+        </p:nvSpPr>
+        <p:spPr>
+          <a:xfrm>
+            <a:off x="9007200" y="1350000"/>
+            <a:ext cx="2700000" cy="1000000"/>
+          </a:xfrm>
+          <a:prstGeom prst="roundRect">
+            <a:avLst/>
+          </a:prstGeom>
+          <a:solidFill>
+            <a:srgbClr val="1F1F4C"/>
+          </a:solidFill>
+          <a:ln>
+            <a:noFill/>
+          </a:ln>
+          <a:effectLst/>
+        </p:spPr>
+        <p:style>
+          <a:lnRef idx="1">
+            <a:schemeClr val="accent1"/>
+          </a:lnRef>
+          <a:fillRef idx="3">
+            <a:schemeClr val="accent1"/>
+          </a:fillRef>
+          <a:effectRef idx="2">
+            <a:schemeClr val="accent1"/>
+          </a:effectRef>
+          <a:fontRef idx="minor">
+            <a:schemeClr val="lt1"/>
+          </a:fontRef>
+        </p:style>
+        <p:txBody>
+          <a:bodyPr rtlCol="0" anchor="ctr"/>
+          <a:lstStyle/>
+          <a:p>
+            <a:pPr algn="ctr"/>
+          </a:p>
+        </p:txBody>
+      </p:sp>
+      <p:sp>
+        <p:nvSpPr>
+          <p:cNvPr id="19" name="TextBox 18"/>
+          <p:cNvSpPr txBox="1"/>
+          <p:nvPr/>
+        </p:nvSpPr>
+        <p:spPr>
+          <a:xfrm>
+            <a:off x="9007200" y="1400000"/>
+            <a:ext cx="2700000" cy="550000"/>
+          </a:xfrm>
+          <a:prstGeom prst="rect">
+            <a:avLst/>
+          </a:prstGeom>
+          <a:noFill/>
+        </p:spPr>
+        <p:txBody>
+          <a:bodyPr wrap="square" lIns="36000" rIns="36000" tIns="0" bIns="0" anchor="ctr">
+            <a:spAutoFit/>
+          </a:bodyPr>
+          <a:lstStyle/>
+          <a:p>
+            <a:pPr algn="ctr"/>
+            <a:r>
+              <a:rPr sz="2200" b="1" i="0">
+                <a:solidFill>
+                  <a:srgbClr val="FFFFFF"/>
+                </a:solidFill>
+                <a:latin typeface="DM Sans"/>
+              </a:rPr>
+              <a:t>27/04 → 31/08</a:t>
+            </a:r>
+          </a:p>
+        </p:txBody>
+      </p:sp>
+      <p:sp>
+        <p:nvSpPr>
+          <p:cNvPr id="20" name="TextBox 19"/>
+          <p:cNvSpPr txBox="1"/>
+          <p:nvPr/>
+        </p:nvSpPr>
+        <p:spPr>
+          <a:xfrm>
+            <a:off x="9007200" y="1950000"/>
+            <a:ext cx="2700000" cy="300000"/>
+          </a:xfrm>
+          <a:prstGeom prst="rect">
+            <a:avLst/>
+          </a:prstGeom>
+          <a:noFill/>
+        </p:spPr>
+        <p:txBody>
+          <a:bodyPr wrap="square" lIns="36000" rIns="36000" tIns="0" bIns="0" anchor="ctr">
+            <a:spAutoFit/>
+          </a:bodyPr>
+          <a:lstStyle/>
+          <a:p>
+            <a:pPr algn="ctr"/>
+            <a:r>
+              <a:rPr sz="1000" b="0" i="0">
+                <a:solidFill>
+                  <a:srgbClr val="B5E622"/>
+                </a:solidFill>
+                <a:latin typeface="DM Sans"/>
+              </a:rPr>
+              <a:t>1ª e última energização</a:t>
+            </a:r>
+          </a:p>
+        </p:txBody>
+      </p:sp>
+      <p:graphicFrame>
+        <p:nvGraphicFramePr>
+          <p:cNvPr id="21" name="Table 20"/>
+          <p:cNvGraphicFramePr>
+            <a:graphicFrameLocks noGrp="1"/>
+          </p:cNvGraphicFramePr>
+          <p:nvPr/>
+        </p:nvGraphicFramePr>
+        <p:xfrm>
+          <a:off x="457200" y="2650000"/>
+          <a:ext cx="11200000" cy="2520000"/>
+        </p:xfrm>
+        <a:graphic>
+          <a:graphicData uri="http://schemas.openxmlformats.org/drawingml/2006/table">
+            <a:tbl>
+              <a:tblPr firstRow="0" bandRow="0">
+                <a:tableStyleId>{2D5ABB26-0587-4C30-8999-92F81FD0307C}</a:tableStyleId>
+              </a:tblPr>
+              <a:tblGrid>
+                <a:gridCol w="2600000"/>
+                <a:gridCol w="4600000"/>
+                <a:gridCol w="2200000"/>
+                <a:gridCol w="1800000"/>
+              </a:tblGrid>
+              <a:tr h="420000">
+                <a:tc>
+                  <a:txBody>
+                    <a:bodyPr wrap="square"/>
+                    <a:lstStyle/>
+                    <a:p>
+                      <a:pPr algn="l"/>
+                      <a:r>
+                        <a:rPr sz="1100" b="1">
+                          <a:solidFill>
+                            <a:srgbClr val="FFFFFF"/>
+                          </a:solidFill>
+                          <a:latin typeface="DM Sans"/>
+                        </a:rPr>
+                        <a:t>Energização</a:t>
+                      </a:r>
+                    </a:p>
+                  </a:txBody>
+                  <a:tcPr marL="45000" marR="45000" marT="15000" marB="15000" anchor="ctr">
+                    <a:solidFill>
+                      <a:srgbClr val="1F1F4C"/>
+                    </a:solidFill>
+                  </a:tcPr>
+                </a:tc>
+                <a:tc>
+                  <a:txBody>
+                    <a:bodyPr wrap="square"/>
+                    <a:lstStyle/>
+                    <a:p>
+                      <a:pPr algn="l"/>
+                      <a:r>
+                        <a:rPr sz="1100" b="1">
+                          <a:solidFill>
+                            <a:srgbClr val="FFFFFF"/>
+                          </a:solidFill>
+                          <a:latin typeface="DM Sans"/>
+                        </a:rPr>
+                        <a:t>SIGCO</a:t>
+                      </a:r>
+                    </a:p>
+                  </a:txBody>
+                  <a:tcPr marL="45000" marR="45000" marT="15000" marB="15000" anchor="ctr">
+                    <a:solidFill>
+                      <a:srgbClr val="1F1F4C"/>
+                    </a:solidFill>
+                  </a:tcPr>
+                </a:tc>
+                <a:tc>
+                  <a:txBody>
+                    <a:bodyPr wrap="square"/>
+                    <a:lstStyle/>
+                    <a:p>
+                      <a:pPr algn="ctr"/>
+                      <a:r>
+                        <a:rPr sz="1100" b="1">
+                          <a:solidFill>
+                            <a:srgbClr val="FFFFFF"/>
+                          </a:solidFill>
+                          <a:latin typeface="DM Sans"/>
+                        </a:rPr>
+                        <a:t>Equipamentos</a:t>
+                      </a:r>
+                    </a:p>
+                  </a:txBody>
+                  <a:tcPr marL="45000" marR="45000" marT="15000" marB="15000" anchor="ctr">
+                    <a:solidFill>
+                      <a:srgbClr val="1F1F4C"/>
+                    </a:solidFill>
+                  </a:tcPr>
+                </a:tc>
+                <a:tc>
+                  <a:txBody>
+                    <a:bodyPr wrap="square"/>
+                    <a:lstStyle/>
+                    <a:p>
+                      <a:pPr algn="r"/>
+                      <a:r>
+                        <a:rPr sz="1100" b="1">
+                          <a:solidFill>
+                            <a:srgbClr val="FFFFFF"/>
+                          </a:solidFill>
+                          <a:latin typeface="DM Sans"/>
+                        </a:rPr>
+                        <a:t>Orç. 2027 (R$ mil)</a:t>
+                      </a:r>
+                    </a:p>
+                  </a:txBody>
+                  <a:tcPr marL="45000" marR="45000" marT="15000" marB="15000" anchor="ctr">
+                    <a:solidFill>
+                      <a:srgbClr val="1F1F4C"/>
+                    </a:solidFill>
+                  </a:tcPr>
+                </a:tc>
+              </a:tr>
+              <a:tr h="420000">
+                <a:tc>
+                  <a:txBody>
+                    <a:bodyPr wrap="square"/>
+                    <a:lstStyle/>
+                    <a:p>
+                      <a:pPr algn="l"/>
+                      <a:r>
+                        <a:rPr sz="1100">
+                          <a:solidFill>
+                            <a:srgbClr val="4D4D4D"/>
+                          </a:solidFill>
+                          <a:latin typeface="DM Sans"/>
+                        </a:rPr>
+                        <a:t>Abr/27 (até 30/04)</a:t>
+                      </a:r>
+                    </a:p>
+                  </a:txBody>
+                  <a:tcPr marL="45000" marR="45000" marT="15000" marB="15000" anchor="ctr">
+                    <a:solidFill>
+                      <a:srgbClr val="FFFFFF"/>
+                    </a:solidFill>
+                  </a:tcPr>
+                </a:tc>
+                <a:tc>
+                  <a:txBody>
+                    <a:bodyPr wrap="square"/>
+                    <a:lstStyle/>
+                    <a:p>
+                      <a:pPr algn="l"/>
+                      <a:r>
+                        <a:rPr sz="1100">
+                          <a:solidFill>
+                            <a:srgbClr val="4D4D4D"/>
+                          </a:solidFill>
+                          <a:latin typeface="DM Sans"/>
+                        </a:rPr>
+                        <a:t>90811</a:t>
+                      </a:r>
+                    </a:p>
+                  </a:txBody>
+                  <a:tcPr marL="45000" marR="45000" marT="15000" marB="15000" anchor="ctr">
+                    <a:solidFill>
+                      <a:srgbClr val="FFFFFF"/>
+                    </a:solidFill>
+                  </a:tcPr>
+                </a:tc>
+                <a:tc>
+                  <a:txBody>
+                    <a:bodyPr wrap="square"/>
+                    <a:lstStyle/>
+                    <a:p>
+                      <a:pPr algn="ctr"/>
+                      <a:r>
+                        <a:rPr sz="1100">
+                          <a:solidFill>
+                            <a:srgbClr val="4D4D4D"/>
+                          </a:solidFill>
+                          <a:latin typeface="DM Sans"/>
+                        </a:rPr>
+                        <a:t>4 RL · 3 RT</a:t>
+                      </a:r>
+                    </a:p>
+                  </a:txBody>
+                  <a:tcPr marL="45000" marR="45000" marT="15000" marB="15000" anchor="ctr">
+                    <a:solidFill>
+                      <a:srgbClr val="FFFFFF"/>
+                    </a:solidFill>
+                  </a:tcPr>
+                </a:tc>
+                <a:tc>
+                  <a:txBody>
+                    <a:bodyPr wrap="square"/>
+                    <a:lstStyle/>
+                    <a:p>
+                      <a:pPr algn="r"/>
+                      <a:r>
+                        <a:rPr sz="1100">
+                          <a:solidFill>
+                            <a:srgbClr val="4D4D4D"/>
+                          </a:solidFill>
+                          <a:latin typeface="DM Sans"/>
+                        </a:rPr>
+                        <a:t>1.802</a:t>
+                      </a:r>
+                    </a:p>
+                  </a:txBody>
+                  <a:tcPr marL="45000" marR="45000" marT="15000" marB="15000" anchor="ctr">
+                    <a:solidFill>
+                      <a:srgbClr val="FFFFFF"/>
+                    </a:solidFill>
+                  </a:tcPr>
+                </a:tc>
+              </a:tr>
+              <a:tr h="420000">
+                <a:tc>
+                  <a:txBody>
+                    <a:bodyPr wrap="square"/>
+                    <a:lstStyle/>
+                    <a:p>
+                      <a:pPr algn="l"/>
+                      <a:r>
+                        <a:rPr sz="1100">
+                          <a:solidFill>
+                            <a:srgbClr val="4D4D4D"/>
+                          </a:solidFill>
+                          <a:latin typeface="DM Sans"/>
+                        </a:rPr>
+                        <a:t>Mai/27 (até 31/05)</a:t>
+                      </a:r>
+                    </a:p>
+                  </a:txBody>
+                  <a:tcPr marL="45000" marR="45000" marT="15000" marB="15000" anchor="ctr">
+                    <a:solidFill>
+                      <a:srgbClr val="F3F5F8"/>
+                    </a:solidFill>
+                  </a:tcPr>
+                </a:tc>
+                <a:tc>
+                  <a:txBody>
+                    <a:bodyPr wrap="square"/>
+                    <a:lstStyle/>
+                    <a:p>
+                      <a:pPr algn="l"/>
+                      <a:r>
+                        <a:rPr sz="1100">
+                          <a:solidFill>
+                            <a:srgbClr val="4D4D4D"/>
+                          </a:solidFill>
+                          <a:latin typeface="DM Sans"/>
+                        </a:rPr>
+                        <a:t>89267, 91979, 92118</a:t>
+                      </a:r>
+                    </a:p>
+                  </a:txBody>
+                  <a:tcPr marL="45000" marR="45000" marT="15000" marB="15000" anchor="ctr">
+                    <a:solidFill>
+                      <a:srgbClr val="F3F5F8"/>
+                    </a:solidFill>
+                  </a:tcPr>
+                </a:tc>
+                <a:tc>
+                  <a:txBody>
+                    <a:bodyPr wrap="square"/>
+                    <a:lstStyle/>
+                    <a:p>
+                      <a:pPr algn="ctr"/>
+                      <a:r>
+                        <a:rPr sz="1100">
+                          <a:solidFill>
+                            <a:srgbClr val="4D4D4D"/>
+                          </a:solidFill>
+                          <a:latin typeface="DM Sans"/>
+                        </a:rPr>
+                        <a:t>2 RL · 2 RT</a:t>
+                      </a:r>
+                    </a:p>
+                  </a:txBody>
+                  <a:tcPr marL="45000" marR="45000" marT="15000" marB="15000" anchor="ctr">
+                    <a:solidFill>
+                      <a:srgbClr val="F3F5F8"/>
+                    </a:solidFill>
+                  </a:tcPr>
+                </a:tc>
+                <a:tc>
+                  <a:txBody>
+                    <a:bodyPr wrap="square"/>
+                    <a:lstStyle/>
+                    <a:p>
+                      <a:pPr algn="r"/>
+                      <a:r>
+                        <a:rPr sz="1100">
+                          <a:solidFill>
+                            <a:srgbClr val="4D4D4D"/>
+                          </a:solidFill>
+                          <a:latin typeface="DM Sans"/>
+                        </a:rPr>
+                        <a:t>1.153</a:t>
+                      </a:r>
+                    </a:p>
+                  </a:txBody>
+                  <a:tcPr marL="45000" marR="45000" marT="15000" marB="15000" anchor="ctr">
+                    <a:solidFill>
+                      <a:srgbClr val="F3F5F8"/>
+                    </a:solidFill>
+                  </a:tcPr>
+                </a:tc>
+              </a:tr>
+              <a:tr h="420000">
+                <a:tc>
+                  <a:txBody>
+                    <a:bodyPr wrap="square"/>
+                    <a:lstStyle/>
+                    <a:p>
+                      <a:pPr algn="l"/>
+                      <a:r>
+                        <a:rPr sz="1100">
+                          <a:solidFill>
+                            <a:srgbClr val="4D4D4D"/>
+                          </a:solidFill>
+                          <a:latin typeface="DM Sans"/>
+                        </a:rPr>
+                        <a:t>Jun/27 (até 30/06)</a:t>
+                      </a:r>
+                    </a:p>
+                  </a:txBody>
+                  <a:tcPr marL="45000" marR="45000" marT="15000" marB="15000" anchor="ctr">
+                    <a:solidFill>
+                      <a:srgbClr val="FFFFFF"/>
+                    </a:solidFill>
+                  </a:tcPr>
+                </a:tc>
+                <a:tc>
+                  <a:txBody>
+                    <a:bodyPr wrap="square"/>
+                    <a:lstStyle/>
+                    <a:p>
+                      <a:pPr algn="l"/>
+                      <a:r>
+                        <a:rPr sz="1100">
+                          <a:solidFill>
+                            <a:srgbClr val="4D4D4D"/>
+                          </a:solidFill>
+                          <a:latin typeface="DM Sans"/>
+                        </a:rPr>
+                        <a:t>70838, 70978, 92094, 92095, 92101, 92102</a:t>
+                      </a:r>
+                    </a:p>
+                  </a:txBody>
+                  <a:tcPr marL="45000" marR="45000" marT="15000" marB="15000" anchor="ctr">
+                    <a:solidFill>
+                      <a:srgbClr val="FFFFFF"/>
+                    </a:solidFill>
+                  </a:tcPr>
+                </a:tc>
+                <a:tc>
+                  <a:txBody>
+                    <a:bodyPr wrap="square"/>
+                    <a:lstStyle/>
+                    <a:p>
+                      <a:pPr algn="ctr"/>
+                      <a:r>
+                        <a:rPr sz="1100">
+                          <a:solidFill>
+                            <a:srgbClr val="4D4D4D"/>
+                          </a:solidFill>
+                          <a:latin typeface="DM Sans"/>
+                        </a:rPr>
+                        <a:t>6 RL · 2 RT</a:t>
+                      </a:r>
+                    </a:p>
+                  </a:txBody>
+                  <a:tcPr marL="45000" marR="45000" marT="15000" marB="15000" anchor="ctr">
+                    <a:solidFill>
+                      <a:srgbClr val="FFFFFF"/>
+                    </a:solidFill>
+                  </a:tcPr>
+                </a:tc>
+                <a:tc>
+                  <a:txBody>
+                    <a:bodyPr wrap="square"/>
+                    <a:lstStyle/>
+                    <a:p>
+                      <a:pPr algn="r"/>
+                      <a:r>
+                        <a:rPr sz="1100">
+                          <a:solidFill>
+                            <a:srgbClr val="4D4D4D"/>
+                          </a:solidFill>
+                          <a:latin typeface="DM Sans"/>
+                        </a:rPr>
+                        <a:t>1.542</a:t>
+                      </a:r>
+                    </a:p>
+                  </a:txBody>
+                  <a:tcPr marL="45000" marR="45000" marT="15000" marB="15000" anchor="ctr">
+                    <a:solidFill>
+                      <a:srgbClr val="FFFFFF"/>
+                    </a:solidFill>
+                  </a:tcPr>
+                </a:tc>
+              </a:tr>
+              <a:tr h="420000">
+                <a:tc>
+                  <a:txBody>
+                    <a:bodyPr wrap="square"/>
+                    <a:lstStyle/>
+                    <a:p>
+                      <a:pPr algn="l"/>
+                      <a:r>
+                        <a:rPr sz="1100">
+                          <a:solidFill>
+                            <a:srgbClr val="4D4D4D"/>
+                          </a:solidFill>
+                          <a:latin typeface="DM Sans"/>
+                        </a:rPr>
+                        <a:t>Ago/27 (até 31/08)</a:t>
+                      </a:r>
+                    </a:p>
+                  </a:txBody>
+                  <a:tcPr marL="45000" marR="45000" marT="15000" marB="15000" anchor="ctr">
+                    <a:solidFill>
+                      <a:srgbClr val="F3F5F8"/>
+                    </a:solidFill>
+                  </a:tcPr>
+                </a:tc>
+                <a:tc>
+                  <a:txBody>
+                    <a:bodyPr wrap="square"/>
+                    <a:lstStyle/>
+                    <a:p>
+                      <a:pPr algn="l"/>
+                      <a:r>
+                        <a:rPr sz="1100">
+                          <a:solidFill>
+                            <a:srgbClr val="4D4D4D"/>
+                          </a:solidFill>
+                          <a:latin typeface="DM Sans"/>
+                        </a:rPr>
+                        <a:t>89249, 89307</a:t>
+                      </a:r>
+                    </a:p>
+                  </a:txBody>
+                  <a:tcPr marL="45000" marR="45000" marT="15000" marB="15000" anchor="ctr">
+                    <a:solidFill>
+                      <a:srgbClr val="F3F5F8"/>
+                    </a:solidFill>
+                  </a:tcPr>
+                </a:tc>
+                <a:tc>
+                  <a:txBody>
+                    <a:bodyPr wrap="square"/>
+                    <a:lstStyle/>
+                    <a:p>
+                      <a:pPr algn="ctr"/>
+                      <a:r>
+                        <a:rPr sz="1100">
+                          <a:solidFill>
+                            <a:srgbClr val="4D4D4D"/>
+                          </a:solidFill>
+                          <a:latin typeface="DM Sans"/>
+                        </a:rPr>
+                        <a:t>0 RL · 2 RT</a:t>
+                      </a:r>
+                    </a:p>
+                  </a:txBody>
+                  <a:tcPr marL="45000" marR="45000" marT="15000" marB="15000" anchor="ctr">
+                    <a:solidFill>
+                      <a:srgbClr val="F3F5F8"/>
+                    </a:solidFill>
+                  </a:tcPr>
+                </a:tc>
+                <a:tc>
+                  <a:txBody>
+                    <a:bodyPr wrap="square"/>
+                    <a:lstStyle/>
+                    <a:p>
+                      <a:pPr algn="r"/>
+                      <a:r>
+                        <a:rPr sz="1100">
+                          <a:solidFill>
+                            <a:srgbClr val="4D4D4D"/>
+                          </a:solidFill>
+                          <a:latin typeface="DM Sans"/>
+                        </a:rPr>
+                        <a:t>731</a:t>
+                      </a:r>
+                    </a:p>
+                  </a:txBody>
+                  <a:tcPr marL="45000" marR="45000" marT="15000" marB="15000" anchor="ctr">
+                    <a:solidFill>
+                      <a:srgbClr val="F3F5F8"/>
+                    </a:solidFill>
+                  </a:tcPr>
+                </a:tc>
+              </a:tr>
+              <a:tr h="420000">
+                <a:tc>
+                  <a:txBody>
+                    <a:bodyPr wrap="square"/>
+                    <a:lstStyle/>
+                    <a:p>
+                      <a:pPr algn="l"/>
+                      <a:r>
+                        <a:rPr sz="1100" b="1">
+                          <a:solidFill>
+                            <a:srgbClr val="1F1F4C"/>
+                          </a:solidFill>
+                          <a:latin typeface="DM Sans"/>
+                        </a:rPr>
+                        <a:t>TOTAL</a:t>
+                      </a:r>
+                    </a:p>
+                  </a:txBody>
+                  <a:tcPr marL="45000" marR="45000" marT="15000" marB="15000" anchor="ctr">
+                    <a:solidFill>
+                      <a:srgbClr val="E3E6F0"/>
+                    </a:solidFill>
+                  </a:tcPr>
+                </a:tc>
+                <a:tc>
+                  <a:txBody>
+                    <a:bodyPr wrap="square"/>
+                    <a:lstStyle/>
+                    <a:p>
+                      <a:pPr algn="l"/>
+                      <a:r>
+                        <a:rPr sz="1100" b="1">
+                          <a:solidFill>
+                            <a:srgbClr val="1F1F4C"/>
+                          </a:solidFill>
+                          <a:latin typeface="DM Sans"/>
+                        </a:rPr>
+                        <a:t>12 SIGCO</a:t>
+                      </a:r>
+                    </a:p>
+                  </a:txBody>
+                  <a:tcPr marL="45000" marR="45000" marT="15000" marB="15000" anchor="ctr">
+                    <a:solidFill>
+                      <a:srgbClr val="E3E6F0"/>
+                    </a:solidFill>
+                  </a:tcPr>
+                </a:tc>
+                <a:tc>
+                  <a:txBody>
+                    <a:bodyPr wrap="square"/>
+                    <a:lstStyle/>
+                    <a:p>
+                      <a:pPr algn="ctr"/>
+                      <a:r>
+                        <a:rPr sz="1100" b="1">
+                          <a:solidFill>
+                            <a:srgbClr val="1F1F4C"/>
+                          </a:solidFill>
+                          <a:latin typeface="DM Sans"/>
+                        </a:rPr>
+                        <a:t>12 RL · 9 RT</a:t>
+                      </a:r>
+                    </a:p>
+                  </a:txBody>
+                  <a:tcPr marL="45000" marR="45000" marT="15000" marB="15000" anchor="ctr">
+                    <a:solidFill>
+                      <a:srgbClr val="E3E6F0"/>
+                    </a:solidFill>
+                  </a:tcPr>
+                </a:tc>
+                <a:tc>
+                  <a:txBody>
+                    <a:bodyPr wrap="square"/>
+                    <a:lstStyle/>
+                    <a:p>
+                      <a:pPr algn="r"/>
+                      <a:r>
+                        <a:rPr sz="1100" b="1">
+                          <a:solidFill>
+                            <a:srgbClr val="1F1F4C"/>
+                          </a:solidFill>
+                          <a:latin typeface="DM Sans"/>
+                        </a:rPr>
+                        <a:t>5.227</a:t>
+                      </a:r>
+                    </a:p>
+                  </a:txBody>
+                  <a:tcPr marL="45000" marR="45000" marT="15000" marB="15000" anchor="ctr">
+                    <a:solidFill>
+                      <a:srgbClr val="E3E6F0"/>
+                    </a:solidFill>
+                  </a:tcPr>
+                </a:tc>
+              </a:tr>
+            </a:tbl>
+          </a:graphicData>
+        </a:graphic>
+      </p:graphicFrame>
+      <p:sp>
+        <p:nvSpPr>
+          <p:cNvPr id="22" name="TextBox 21"/>
+          <p:cNvSpPr txBox="1"/>
+          <p:nvPr/>
+        </p:nvSpPr>
+        <p:spPr>
+          <a:xfrm>
+            <a:off x="457200" y="5270000"/>
+            <a:ext cx="11200000" cy="350000"/>
+          </a:xfrm>
+          <a:prstGeom prst="rect">
+            <a:avLst/>
+          </a:prstGeom>
+          <a:noFill/>
+        </p:spPr>
+        <p:txBody>
+          <a:bodyPr wrap="square" lIns="36000" rIns="36000" tIns="0" bIns="0" anchor="t">
+            <a:spAutoFit/>
+          </a:bodyPr>
+          <a:lstStyle/>
+          <a:p>
+            <a:pPr algn="l"/>
+            <a:r>
+              <a:rPr sz="1000" b="0" i="1">
+                <a:solidFill>
+                  <a:srgbClr val="4D4D4D"/>
+                </a:solidFill>
+                <a:latin typeface="DM Sans"/>
+              </a:rPr>
+              <a:t>Pontos de atenção: 6 projetos energizam em 30/06; 90811 é o primeiro marco (27/04) e exige início de execução em 16/02/2027; diferença de orçamento ago/26 × curva out/26 a conciliar.</a:t>
+            </a:r>
+          </a:p>
+        </p:txBody>
+      </p:sp>
+    </p:spTree>
+  </p:cSld>
+  <p:clrMapOvr>
+    <a:masterClrMapping/>
+  </p:clrMapOvr>
+</p:sld>
+</file>
+
+<file path=ppt/slides/slide21.xml><?xml version="1.0" encoding="utf-8"?>
+<p:sld xmlns:a="http://schemas.openxmlformats.org/drawingml/2006/main" xmlns:p="http://schemas.openxmlformats.org/presentationml/2006/main" xmlns:r="http://schemas.openxmlformats.org/officeDocument/2006/relationships">
+  <p:cSld>
+    <p:spTree>
+      <p:nvGrpSpPr>
+        <p:cNvPr id="1" name=""/>
+        <p:cNvGrpSpPr/>
+        <p:nvPr/>
+      </p:nvGrpSpPr>
+      <p:grpSpPr/>
+      <p:sp>
+        <p:nvSpPr>
+          <p:cNvPr id="6" name="Title 2">
+            <a:extLst>
+              <a:ext uri="{FF2B5EF4-FFF2-40B4-BE49-F238E27FC236}">
+                <a16:creationId xmlns:a16="http://schemas.microsoft.com/office/drawing/2014/main" id="{BBAC4CB0-69CB-452A-4A56-4E4A151CF2C1}"/>
+              </a:ext>
+            </a:extLst>
+          </p:cNvPr>
+          <p:cNvSpPr txBox="1">
+            <a:spLocks/>
+          </p:cNvSpPr>
+          <p:nvPr/>
+        </p:nvSpPr>
+        <p:spPr>
+          <a:xfrm>
+            <a:off x="457200" y="566928"/>
+            <a:ext cx="7790688" cy="566928"/>
+          </a:xfrm>
+          <a:prstGeom prst="rect">
+            <a:avLst/>
+          </a:prstGeom>
+        </p:spPr>
+        <p:txBody>
+          <a:bodyPr lIns="0" tIns="0" rIns="0" bIns="0" anchor="ctr"/>
+          <a:lstStyle>
+            <a:lvl1pPr algn="l" defTabSz="914400" rtl="0" eaLnBrk="1" latinLnBrk="0" hangingPunct="1">
+              <a:lnSpc>
+                <a:spcPct val="90000"/>
+              </a:lnSpc>
+              <a:spcBef>
+                <a:spcPct val="0"/>
+              </a:spcBef>
+              <a:buNone/>
+              <a:defRPr sz="4400" kern="1200">
+                <a:solidFill>
+                  <a:schemeClr val="tx1"/>
+                </a:solidFill>
+                <a:latin typeface="+mj-lt"/>
+                <a:ea typeface="+mj-ea"/>
+                <a:cs typeface="+mj-cs"/>
+              </a:defRPr>
+            </a:lvl1pPr>
+          </a:lstStyle>
+          <a:p>
+            <a:r>
+              <a:rPr lang="pt-BR" sz="3000" b="1">
+                <a:solidFill>
+                  <a:srgbClr val="1F1F4C"/>
+                </a:solidFill>
+                <a:latin typeface="DM Sans"/>
+              </a:rPr>
+              <a:t>Desembolso Mensal 2027</a:t>
+            </a:r>
+          </a:p>
+        </p:txBody>
+      </p:sp>
+      <p:sp>
+        <p:nvSpPr>
+          <p:cNvPr id="7" name="Eyebrow">
+            <a:extLst>
+              <a:ext uri="{FF2B5EF4-FFF2-40B4-BE49-F238E27FC236}">
+                <a16:creationId xmlns:a16="http://schemas.microsoft.com/office/drawing/2014/main" id="{50824C48-A21F-0B29-3A2A-0036E3CE3299}"/>
+              </a:ext>
+            </a:extLst>
+          </p:cNvPr>
+          <p:cNvSpPr txBox="1"/>
+          <p:nvPr/>
+        </p:nvSpPr>
+        <p:spPr>
+          <a:xfrm>
+            <a:off x="457200" y="347472"/>
+            <a:ext cx="7315200" cy="169277"/>
+          </a:xfrm>
+          <a:prstGeom prst="rect">
+            <a:avLst/>
+          </a:prstGeom>
+          <a:noFill/>
+        </p:spPr>
+        <p:txBody>
+          <a:bodyPr wrap="square" lIns="0" tIns="0" rIns="0" bIns="0" anchor="t">
+            <a:spAutoFit/>
+          </a:bodyPr>
+          <a:lstStyle/>
+          <a:p>
+            <a:pPr algn="l"/>
+            <a:r>
+              <a:rPr sz="1100" b="1" i="0" spc="150">
+                <a:solidFill>
+                  <a:srgbClr val="F47B20"/>
+                </a:solidFill>
+                <a:latin typeface="DM Sans"/>
+              </a:rPr>
+              <a:t>KICKOFF MEETING</a:t>
+            </a:r>
+            <a:r>
+              <a:rPr sz="1100" b="1" i="0" spc="150">
+                <a:solidFill>
+                  <a:srgbClr val="989898"/>
+                </a:solidFill>
+                <a:latin typeface="DM Sans"/>
+              </a:rPr>
+              <a:t>   |   PN 2027  ·  OBRAS DCMD – RL / RT</a:t>
+            </a:r>
+            <a:r>
+              <a:rPr lang="pt-BR" sz="1100" b="1" i="0" spc="150">
+                <a:solidFill>
+                  <a:srgbClr val="989898"/>
+                </a:solidFill>
+                <a:latin typeface="DM Sans"/>
+              </a:rPr>
+              <a:t/>
+            </a:r>
+            <a:endParaRPr sz="1100" b="1" i="0" spc="150">
+              <a:solidFill>
+                <a:srgbClr val="989898"/>
+              </a:solidFill>
+              <a:latin typeface="DM Sans"/>
+            </a:endParaRPr>
+          </a:p>
+        </p:txBody>
+      </p:sp>
+      <p:sp>
+        <p:nvSpPr>
+          <p:cNvPr id="8" name="Rodapé">
+            <a:extLst>
+              <a:ext uri="{FF2B5EF4-FFF2-40B4-BE49-F238E27FC236}">
+                <a16:creationId xmlns:a16="http://schemas.microsoft.com/office/drawing/2014/main" id="{8F7B4335-BE0B-DF62-CED3-FA23D73E207F}"/>
+              </a:ext>
+            </a:extLst>
+          </p:cNvPr>
+          <p:cNvSpPr txBox="1"/>
+          <p:nvPr/>
+        </p:nvSpPr>
+        <p:spPr>
+          <a:xfrm>
+            <a:off x="457200" y="6428232"/>
+            <a:ext cx="7315200" cy="153888"/>
+          </a:xfrm>
+          <a:prstGeom prst="rect">
+            <a:avLst/>
+          </a:prstGeom>
+          <a:noFill/>
+        </p:spPr>
+        <p:txBody>
+          <a:bodyPr wrap="square" lIns="0" tIns="0" rIns="0" bIns="0" anchor="t">
+            <a:spAutoFit/>
+          </a:bodyPr>
+          <a:lstStyle/>
+          <a:p>
+            <a:pPr algn="l"/>
+            <a:r>
+              <a:rPr sz="1000" b="1" i="0">
+                <a:solidFill>
+                  <a:srgbClr val="1F1F4C"/>
+                </a:solidFill>
+                <a:latin typeface="DM Sans"/>
+              </a:rPr>
+              <a:t>06  ·  OBRAS DCMD – RL / RT  ·  PN 2027</a:t>
+            </a:r>
+            <a:r>
+              <a:rPr lang="pt-BR" sz="1000" b="1">
+                <a:solidFill>
+                  <a:srgbClr val="1F1F4C"/>
+                </a:solidFill>
+                <a:latin typeface="DM Sans"/>
+              </a:rPr>
+              <a:t/>
+            </a:r>
+            <a:r>
+              <a:rPr sz="900" b="0" i="0">
+                <a:solidFill>
+                  <a:srgbClr val="989898"/>
+                </a:solidFill>
+                <a:latin typeface="DM Sans"/>
+              </a:rPr>
+              <a:t/>
+            </a:r>
+            <a:r>
+              <a:rPr lang="pt-BR" sz="900" b="0" i="0">
+                <a:solidFill>
+                  <a:srgbClr val="989898"/>
+                </a:solidFill>
+                <a:latin typeface="DM Sans"/>
+              </a:rPr>
+              <a:t/>
+            </a:r>
+            <a:endParaRPr sz="900" b="0" i="0">
+              <a:solidFill>
+                <a:srgbClr val="989898"/>
+              </a:solidFill>
+              <a:latin typeface="DM Sans"/>
+            </a:endParaRPr>
+          </a:p>
+        </p:txBody>
+      </p:sp>
+      <p:graphicFrame>
+        <p:nvGraphicFramePr>
+          <p:cNvPr id="9" name="Chart 8"/>
+          <p:cNvGraphicFramePr>
+            <a:graphicFrameLocks noGrp="1"/>
+          </p:cNvGraphicFramePr>
+          <p:nvPr/>
+        </p:nvGraphicFramePr>
+        <p:xfrm>
+          <a:off x="457200" y="1350000"/>
+          <a:ext cx="7300000" cy="4600000"/>
+        </p:xfrm>
+        <a:graphic>
+          <a:graphicData uri="http://schemas.openxmlformats.org/drawingml/2006/chart">
+            <c:chart xmlns:c="http://schemas.openxmlformats.org/drawingml/2006/chart" r:id="rId2"/>
+          </a:graphicData>
+        </a:graphic>
+      </p:graphicFrame>
+      <p:graphicFrame>
+        <p:nvGraphicFramePr>
+          <p:cNvPr id="10" name="Table 9"/>
+          <p:cNvGraphicFramePr>
+            <a:graphicFrameLocks noGrp="1"/>
+          </p:cNvGraphicFramePr>
+          <p:nvPr/>
+        </p:nvGraphicFramePr>
+        <p:xfrm>
+          <a:off x="8000000" y="1350000"/>
+          <a:ext cx="3700000" cy="4290000"/>
+        </p:xfrm>
+        <a:graphic>
+          <a:graphicData uri="http://schemas.openxmlformats.org/drawingml/2006/table">
+            <a:tbl>
+              <a:tblPr firstRow="0" bandRow="0">
+                <a:tableStyleId>{2D5ABB26-0587-4C30-8999-92F81FD0307C}</a:tableStyleId>
+              </a:tblPr>
+              <a:tblGrid>
+                <a:gridCol w="900000"/>
+                <a:gridCol w="1700000"/>
+                <a:gridCol w="1100000"/>
+              </a:tblGrid>
+              <a:tr h="330000">
+                <a:tc>
+                  <a:txBody>
+                    <a:bodyPr wrap="square"/>
+                    <a:lstStyle/>
+                    <a:p>
+                      <a:pPr algn="l"/>
+                      <a:r>
+                        <a:rPr sz="1000" b="1">
+                          <a:solidFill>
+                            <a:srgbClr val="FFFFFF"/>
+                          </a:solidFill>
+                          <a:latin typeface="DM Sans"/>
+                        </a:rPr>
+                        <a:t>Mês</a:t>
+                      </a:r>
+                    </a:p>
+                  </a:txBody>
+                  <a:tcPr marL="45000" marR="45000" marT="15000" marB="15000" anchor="ctr">
+                    <a:solidFill>
+                      <a:srgbClr val="1F1F4C"/>
+                    </a:solidFill>
+                  </a:tcPr>
+                </a:tc>
+                <a:tc>
+                  <a:txBody>
+                    <a:bodyPr wrap="square"/>
+                    <a:lstStyle/>
+                    <a:p>
+                      <a:pPr algn="r"/>
+                      <a:r>
+                        <a:rPr sz="1000" b="1">
+                          <a:solidFill>
+                            <a:srgbClr val="FFFFFF"/>
+                          </a:solidFill>
+                          <a:latin typeface="DM Sans"/>
+                        </a:rPr>
+                        <a:t>Acumulado (R$ mil)</a:t>
+                      </a:r>
+                    </a:p>
+                  </a:txBody>
+                  <a:tcPr marL="45000" marR="45000" marT="15000" marB="15000" anchor="ctr">
+                    <a:solidFill>
+                      <a:srgbClr val="1F1F4C"/>
+                    </a:solidFill>
+                  </a:tcPr>
+                </a:tc>
+                <a:tc>
+                  <a:txBody>
+                    <a:bodyPr wrap="square"/>
+                    <a:lstStyle/>
+                    <a:p>
+                      <a:pPr algn="r"/>
+                      <a:r>
+                        <a:rPr sz="1000" b="1">
+                          <a:solidFill>
+                            <a:srgbClr val="FFFFFF"/>
+                          </a:solidFill>
+                          <a:latin typeface="DM Sans"/>
+                        </a:rPr>
+                        <a:t>% do total</a:t>
+                      </a:r>
+                    </a:p>
+                  </a:txBody>
+                  <a:tcPr marL="45000" marR="45000" marT="15000" marB="15000" anchor="ctr">
+                    <a:solidFill>
+                      <a:srgbClr val="1F1F4C"/>
+                    </a:solidFill>
+                  </a:tcPr>
+                </a:tc>
+              </a:tr>
+              <a:tr h="330000">
+                <a:tc>
+                  <a:txBody>
+                    <a:bodyPr wrap="square"/>
+                    <a:lstStyle/>
+                    <a:p>
+                      <a:pPr algn="l"/>
+                      <a:r>
+                        <a:rPr sz="1000">
+                          <a:solidFill>
+                            <a:srgbClr val="4D4D4D"/>
+                          </a:solidFill>
+                          <a:latin typeface="DM Sans"/>
+                        </a:rPr>
+                        <a:t>Jan</a:t>
+                      </a:r>
+                    </a:p>
+                  </a:txBody>
+                  <a:tcPr marL="45000" marR="45000" marT="15000" marB="15000" anchor="ctr">
+                    <a:solidFill>
+                      <a:srgbClr val="FFFFFF"/>
+                    </a:solidFill>
+                  </a:tcPr>
+                </a:tc>
+                <a:tc>
+                  <a:txBody>
+                    <a:bodyPr wrap="square"/>
+                    <a:lstStyle/>
+                    <a:p>
+                      <a:pPr algn="r"/>
+                      <a:r>
+                        <a:rPr sz="1000">
+                          <a:solidFill>
+                            <a:srgbClr val="4D4D4D"/>
+                          </a:solidFill>
+                          <a:latin typeface="DM Sans"/>
+                        </a:rPr>
+                        <a:t>429</a:t>
+                      </a:r>
+                    </a:p>
+                  </a:txBody>
+                  <a:tcPr marL="45000" marR="45000" marT="15000" marB="15000" anchor="ctr">
+                    <a:solidFill>
+                      <a:srgbClr val="FFFFFF"/>
+                    </a:solidFill>
+                  </a:tcPr>
+                </a:tc>
+                <a:tc>
+                  <a:txBody>
+                    <a:bodyPr wrap="square"/>
+                    <a:lstStyle/>
+                    <a:p>
+                      <a:pPr algn="r"/>
+                      <a:r>
+                        <a:rPr sz="1000">
+                          <a:solidFill>
+                            <a:srgbClr val="4D4D4D"/>
+                          </a:solidFill>
+                          <a:latin typeface="DM Sans"/>
+                        </a:rPr>
+                        <a:t>8%</a:t>
+                      </a:r>
+                    </a:p>
+                  </a:txBody>
+                  <a:tcPr marL="45000" marR="45000" marT="15000" marB="15000" anchor="ctr">
+                    <a:solidFill>
+                      <a:srgbClr val="FFFFFF"/>
+                    </a:solidFill>
+                  </a:tcPr>
+                </a:tc>
+              </a:tr>
+              <a:tr h="330000">
+                <a:tc>
+                  <a:txBody>
+                    <a:bodyPr wrap="square"/>
+                    <a:lstStyle/>
+                    <a:p>
+                      <a:pPr algn="l"/>
+                      <a:r>
+                        <a:rPr sz="1000">
+                          <a:solidFill>
+                            <a:srgbClr val="4D4D4D"/>
+                          </a:solidFill>
+                          <a:latin typeface="DM Sans"/>
+                        </a:rPr>
+                        <a:t>Fev</a:t>
+                      </a:r>
+                    </a:p>
+                  </a:txBody>
+                  <a:tcPr marL="45000" marR="45000" marT="15000" marB="15000" anchor="ctr">
+                    <a:solidFill>
+                      <a:srgbClr val="F3F5F8"/>
+                    </a:solidFill>
+                  </a:tcPr>
+                </a:tc>
+                <a:tc>
+                  <a:txBody>
+                    <a:bodyPr wrap="square"/>
+                    <a:lstStyle/>
+                    <a:p>
+                      <a:pPr algn="r"/>
+                      <a:r>
+                        <a:rPr sz="1000">
+                          <a:solidFill>
+                            <a:srgbClr val="4D4D4D"/>
+                          </a:solidFill>
+                          <a:latin typeface="DM Sans"/>
+                        </a:rPr>
+                        <a:t>858</a:t>
+                      </a:r>
+                    </a:p>
+                  </a:txBody>
+                  <a:tcPr marL="45000" marR="45000" marT="15000" marB="15000" anchor="ctr">
+                    <a:solidFill>
+                      <a:srgbClr val="F3F5F8"/>
+                    </a:solidFill>
+                  </a:tcPr>
+                </a:tc>
+                <a:tc>
+                  <a:txBody>
+                    <a:bodyPr wrap="square"/>
+                    <a:lstStyle/>
+                    <a:p>
+                      <a:pPr algn="r"/>
+                      <a:r>
+                        <a:rPr sz="1000">
+                          <a:solidFill>
+                            <a:srgbClr val="4D4D4D"/>
+                          </a:solidFill>
+                          <a:latin typeface="DM Sans"/>
+                        </a:rPr>
+                        <a:t>16%</a:t>
+                      </a:r>
+                    </a:p>
+                  </a:txBody>
+                  <a:tcPr marL="45000" marR="45000" marT="15000" marB="15000" anchor="ctr">
+                    <a:solidFill>
+                      <a:srgbClr val="F3F5F8"/>
+                    </a:solidFill>
+                  </a:tcPr>
+                </a:tc>
+              </a:tr>
+              <a:tr h="330000">
+                <a:tc>
+                  <a:txBody>
+                    <a:bodyPr wrap="square"/>
+                    <a:lstStyle/>
+                    <a:p>
+                      <a:pPr algn="l"/>
+                      <a:r>
+                        <a:rPr sz="1000">
+                          <a:solidFill>
+                            <a:srgbClr val="4D4D4D"/>
+                          </a:solidFill>
+                          <a:latin typeface="DM Sans"/>
+                        </a:rPr>
+                        <a:t>Mar</a:t>
+                      </a:r>
+                    </a:p>
+                  </a:txBody>
+                  <a:tcPr marL="45000" marR="45000" marT="15000" marB="15000" anchor="ctr">
+                    <a:solidFill>
+                      <a:srgbClr val="FFFFFF"/>
+                    </a:solidFill>
+                  </a:tcPr>
+                </a:tc>
+                <a:tc>
+                  <a:txBody>
+                    <a:bodyPr wrap="square"/>
+                    <a:lstStyle/>
+                    <a:p>
+                      <a:pPr algn="r"/>
+                      <a:r>
+                        <a:rPr sz="1000">
+                          <a:solidFill>
+                            <a:srgbClr val="4D4D4D"/>
+                          </a:solidFill>
+                          <a:latin typeface="DM Sans"/>
+                        </a:rPr>
+                        <a:t>1.286</a:t>
+                      </a:r>
+                    </a:p>
+                  </a:txBody>
+                  <a:tcPr marL="45000" marR="45000" marT="15000" marB="15000" anchor="ctr">
+                    <a:solidFill>
+                      <a:srgbClr val="FFFFFF"/>
+                    </a:solidFill>
+                  </a:tcPr>
+                </a:tc>
+                <a:tc>
+                  <a:txBody>
+                    <a:bodyPr wrap="square"/>
+                    <a:lstStyle/>
+                    <a:p>
+                      <a:pPr algn="r"/>
+                      <a:r>
+                        <a:rPr sz="1000">
+                          <a:solidFill>
+                            <a:srgbClr val="4D4D4D"/>
+                          </a:solidFill>
+                          <a:latin typeface="DM Sans"/>
+                        </a:rPr>
+                        <a:t>25%</a:t>
+                      </a:r>
+                    </a:p>
+                  </a:txBody>
+                  <a:tcPr marL="45000" marR="45000" marT="15000" marB="15000" anchor="ctr">
+                    <a:solidFill>
+                      <a:srgbClr val="FFFFFF"/>
+                    </a:solidFill>
+                  </a:tcPr>
+                </a:tc>
+              </a:tr>
+              <a:tr h="330000">
+                <a:tc>
+                  <a:txBody>
+                    <a:bodyPr wrap="square"/>
+                    <a:lstStyle/>
+                    <a:p>
+                      <a:pPr algn="l"/>
+                      <a:r>
+                        <a:rPr sz="1000">
+                          <a:solidFill>
+                            <a:srgbClr val="4D4D4D"/>
+                          </a:solidFill>
+                          <a:latin typeface="DM Sans"/>
+                        </a:rPr>
+                        <a:t>Abr</a:t>
+                      </a:r>
+                    </a:p>
+                  </a:txBody>
+                  <a:tcPr marL="45000" marR="45000" marT="15000" marB="15000" anchor="ctr">
+                    <a:solidFill>
+                      <a:srgbClr val="F3F5F8"/>
+                    </a:solidFill>
+                  </a:tcPr>
+                </a:tc>
+                <a:tc>
+                  <a:txBody>
+                    <a:bodyPr wrap="square"/>
+                    <a:lstStyle/>
+                    <a:p>
+                      <a:pPr algn="r"/>
+                      <a:r>
+                        <a:rPr sz="1000">
+                          <a:solidFill>
+                            <a:srgbClr val="4D4D4D"/>
+                          </a:solidFill>
+                          <a:latin typeface="DM Sans"/>
+                        </a:rPr>
+                        <a:t>1.715</a:t>
+                      </a:r>
+                    </a:p>
+                  </a:txBody>
+                  <a:tcPr marL="45000" marR="45000" marT="15000" marB="15000" anchor="ctr">
+                    <a:solidFill>
+                      <a:srgbClr val="F3F5F8"/>
+                    </a:solidFill>
+                  </a:tcPr>
+                </a:tc>
+                <a:tc>
+                  <a:txBody>
+                    <a:bodyPr wrap="square"/>
+                    <a:lstStyle/>
+                    <a:p>
+                      <a:pPr algn="r"/>
+                      <a:r>
+                        <a:rPr sz="1000">
+                          <a:solidFill>
+                            <a:srgbClr val="4D4D4D"/>
+                          </a:solidFill>
+                          <a:latin typeface="DM Sans"/>
+                        </a:rPr>
+                        <a:t>33%</a:t>
+                      </a:r>
+                    </a:p>
+                  </a:txBody>
+                  <a:tcPr marL="45000" marR="45000" marT="15000" marB="15000" anchor="ctr">
+                    <a:solidFill>
+                      <a:srgbClr val="F3F5F8"/>
+                    </a:solidFill>
+                  </a:tcPr>
+                </a:tc>
+              </a:tr>
+              <a:tr h="330000">
+                <a:tc>
+                  <a:txBody>
+                    <a:bodyPr wrap="square"/>
+                    <a:lstStyle/>
+                    <a:p>
+                      <a:pPr algn="l"/>
+                      <a:r>
+                        <a:rPr sz="1000">
+                          <a:solidFill>
+                            <a:srgbClr val="4D4D4D"/>
+                          </a:solidFill>
+                          <a:latin typeface="DM Sans"/>
+                        </a:rPr>
+                        <a:t>Mai</a:t>
+                      </a:r>
+                    </a:p>
+                  </a:txBody>
+                  <a:tcPr marL="45000" marR="45000" marT="15000" marB="15000" anchor="ctr">
+                    <a:solidFill>
+                      <a:srgbClr val="FFFFFF"/>
+                    </a:solidFill>
+                  </a:tcPr>
+                </a:tc>
+                <a:tc>
+                  <a:txBody>
+                    <a:bodyPr wrap="square"/>
+                    <a:lstStyle/>
+                    <a:p>
+                      <a:pPr algn="r"/>
+                      <a:r>
+                        <a:rPr sz="1000">
+                          <a:solidFill>
+                            <a:srgbClr val="4D4D4D"/>
+                          </a:solidFill>
+                          <a:latin typeface="DM Sans"/>
+                        </a:rPr>
+                        <a:t>2.164</a:t>
+                      </a:r>
+                    </a:p>
+                  </a:txBody>
+                  <a:tcPr marL="45000" marR="45000" marT="15000" marB="15000" anchor="ctr">
+                    <a:solidFill>
+                      <a:srgbClr val="FFFFFF"/>
+                    </a:solidFill>
+                  </a:tcPr>
+                </a:tc>
+                <a:tc>
+                  <a:txBody>
+                    <a:bodyPr wrap="square"/>
+                    <a:lstStyle/>
+                    <a:p>
+                      <a:pPr algn="r"/>
+                      <a:r>
+                        <a:rPr sz="1000">
+                          <a:solidFill>
+                            <a:srgbClr val="4D4D4D"/>
+                          </a:solidFill>
+                          <a:latin typeface="DM Sans"/>
+                        </a:rPr>
+                        <a:t>41%</a:t>
+                      </a:r>
+                    </a:p>
+                  </a:txBody>
+                  <a:tcPr marL="45000" marR="45000" marT="15000" marB="15000" anchor="ctr">
+                    <a:solidFill>
+                      <a:srgbClr val="FFFFFF"/>
+                    </a:solidFill>
+                  </a:tcPr>
+                </a:tc>
+              </a:tr>
+              <a:tr h="330000">
+                <a:tc>
+                  <a:txBody>
+                    <a:bodyPr wrap="square"/>
+                    <a:lstStyle/>
+                    <a:p>
+                      <a:pPr algn="l"/>
+                      <a:r>
+                        <a:rPr sz="1000">
+                          <a:solidFill>
+                            <a:srgbClr val="4D4D4D"/>
+                          </a:solidFill>
+                          <a:latin typeface="DM Sans"/>
+                        </a:rPr>
+                        <a:t>Jun</a:t>
+                      </a:r>
+                    </a:p>
+                  </a:txBody>
+                  <a:tcPr marL="45000" marR="45000" marT="15000" marB="15000" anchor="ctr">
+                    <a:solidFill>
+                      <a:srgbClr val="F3F5F8"/>
+                    </a:solidFill>
+                  </a:tcPr>
+                </a:tc>
+                <a:tc>
+                  <a:txBody>
+                    <a:bodyPr wrap="square"/>
+                    <a:lstStyle/>
+                    <a:p>
+                      <a:pPr algn="r"/>
+                      <a:r>
+                        <a:rPr sz="1000">
+                          <a:solidFill>
+                            <a:srgbClr val="4D4D4D"/>
+                          </a:solidFill>
+                          <a:latin typeface="DM Sans"/>
+                        </a:rPr>
+                        <a:t>2.613</a:t>
+                      </a:r>
+                    </a:p>
+                  </a:txBody>
+                  <a:tcPr marL="45000" marR="45000" marT="15000" marB="15000" anchor="ctr">
+                    <a:solidFill>
+                      <a:srgbClr val="F3F5F8"/>
+                    </a:solidFill>
+                  </a:tcPr>
+                </a:tc>
+                <a:tc>
+                  <a:txBody>
+                    <a:bodyPr wrap="square"/>
+                    <a:lstStyle/>
+                    <a:p>
+                      <a:pPr algn="r"/>
+                      <a:r>
+                        <a:rPr sz="1000">
+                          <a:solidFill>
+                            <a:srgbClr val="4D4D4D"/>
+                          </a:solidFill>
+                          <a:latin typeface="DM Sans"/>
+                        </a:rPr>
+                        <a:t>50%</a:t>
+                      </a:r>
+                    </a:p>
+                  </a:txBody>
+                  <a:tcPr marL="45000" marR="45000" marT="15000" marB="15000" anchor="ctr">
+                    <a:solidFill>
+                      <a:srgbClr val="F3F5F8"/>
+                    </a:solidFill>
+                  </a:tcPr>
+                </a:tc>
+              </a:tr>
+              <a:tr h="330000">
+                <a:tc>
+                  <a:txBody>
+                    <a:bodyPr wrap="square"/>
+                    <a:lstStyle/>
+                    <a:p>
+                      <a:pPr algn="l"/>
+                      <a:r>
+                        <a:rPr sz="1000">
+                          <a:solidFill>
+                            <a:srgbClr val="4D4D4D"/>
+                          </a:solidFill>
+                          <a:latin typeface="DM Sans"/>
+                        </a:rPr>
+                        <a:t>Jul</a:t>
+                      </a:r>
+                    </a:p>
+                  </a:txBody>
+                  <a:tcPr marL="45000" marR="45000" marT="15000" marB="15000" anchor="ctr">
+                    <a:solidFill>
+                      <a:srgbClr val="FFFFFF"/>
+                    </a:solidFill>
+                  </a:tcPr>
+                </a:tc>
+                <a:tc>
+                  <a:txBody>
+                    <a:bodyPr wrap="square"/>
+                    <a:lstStyle/>
+                    <a:p>
+                      <a:pPr algn="r"/>
+                      <a:r>
+                        <a:rPr sz="1000">
+                          <a:solidFill>
+                            <a:srgbClr val="4D4D4D"/>
+                          </a:solidFill>
+                          <a:latin typeface="DM Sans"/>
+                        </a:rPr>
+                        <a:t>3.063</a:t>
+                      </a:r>
+                    </a:p>
+                  </a:txBody>
+                  <a:tcPr marL="45000" marR="45000" marT="15000" marB="15000" anchor="ctr">
+                    <a:solidFill>
+                      <a:srgbClr val="FFFFFF"/>
+                    </a:solidFill>
+                  </a:tcPr>
+                </a:tc>
+                <a:tc>
+                  <a:txBody>
+                    <a:bodyPr wrap="square"/>
+                    <a:lstStyle/>
+                    <a:p>
+                      <a:pPr algn="r"/>
+                      <a:r>
+                        <a:rPr sz="1000">
+                          <a:solidFill>
+                            <a:srgbClr val="4D4D4D"/>
+                          </a:solidFill>
+                          <a:latin typeface="DM Sans"/>
+                        </a:rPr>
+                        <a:t>59%</a:t>
+                      </a:r>
+                    </a:p>
+                  </a:txBody>
+                  <a:tcPr marL="45000" marR="45000" marT="15000" marB="15000" anchor="ctr">
+                    <a:solidFill>
+                      <a:srgbClr val="FFFFFF"/>
+                    </a:solidFill>
+                  </a:tcPr>
+                </a:tc>
+              </a:tr>
+              <a:tr h="330000">
+                <a:tc>
+                  <a:txBody>
+                    <a:bodyPr wrap="square"/>
+                    <a:lstStyle/>
+                    <a:p>
+                      <a:pPr algn="l"/>
+                      <a:r>
+                        <a:rPr sz="1000">
+                          <a:solidFill>
+                            <a:srgbClr val="4D4D4D"/>
+                          </a:solidFill>
+                          <a:latin typeface="DM Sans"/>
+                        </a:rPr>
+                        <a:t>Ago</a:t>
+                      </a:r>
+                    </a:p>
+                  </a:txBody>
+                  <a:tcPr marL="45000" marR="45000" marT="15000" marB="15000" anchor="ctr">
+                    <a:solidFill>
+                      <a:srgbClr val="F3F5F8"/>
+                    </a:solidFill>
+                  </a:tcPr>
+                </a:tc>
+                <a:tc>
+                  <a:txBody>
+                    <a:bodyPr wrap="square"/>
+                    <a:lstStyle/>
+                    <a:p>
+                      <a:pPr algn="r"/>
+                      <a:r>
+                        <a:rPr sz="1000">
+                          <a:solidFill>
+                            <a:srgbClr val="4D4D4D"/>
+                          </a:solidFill>
+                          <a:latin typeface="DM Sans"/>
+                        </a:rPr>
+                        <a:t>3.512</a:t>
+                      </a:r>
+                    </a:p>
+                  </a:txBody>
+                  <a:tcPr marL="45000" marR="45000" marT="15000" marB="15000" anchor="ctr">
+                    <a:solidFill>
+                      <a:srgbClr val="F3F5F8"/>
+                    </a:solidFill>
+                  </a:tcPr>
+                </a:tc>
+                <a:tc>
+                  <a:txBody>
+                    <a:bodyPr wrap="square"/>
+                    <a:lstStyle/>
+                    <a:p>
+                      <a:pPr algn="r"/>
+                      <a:r>
+                        <a:rPr sz="1000">
+                          <a:solidFill>
+                            <a:srgbClr val="4D4D4D"/>
+                          </a:solidFill>
+                          <a:latin typeface="DM Sans"/>
+                        </a:rPr>
+                        <a:t>67%</a:t>
+                      </a:r>
+                    </a:p>
+                  </a:txBody>
+                  <a:tcPr marL="45000" marR="45000" marT="15000" marB="15000" anchor="ctr">
+                    <a:solidFill>
+                      <a:srgbClr val="F3F5F8"/>
+                    </a:solidFill>
+                  </a:tcPr>
+                </a:tc>
+              </a:tr>
+              <a:tr h="330000">
+                <a:tc>
+                  <a:txBody>
+                    <a:bodyPr wrap="square"/>
+                    <a:lstStyle/>
+                    <a:p>
+                      <a:pPr algn="l"/>
+                      <a:r>
+                        <a:rPr sz="1000">
+                          <a:solidFill>
+                            <a:srgbClr val="4D4D4D"/>
+                          </a:solidFill>
+                          <a:latin typeface="DM Sans"/>
+                        </a:rPr>
+                        <a:t>Set</a:t>
+                      </a:r>
+                    </a:p>
+                  </a:txBody>
+                  <a:tcPr marL="45000" marR="45000" marT="15000" marB="15000" anchor="ctr">
+                    <a:solidFill>
+                      <a:srgbClr val="FFFFFF"/>
+                    </a:solidFill>
+                  </a:tcPr>
+                </a:tc>
+                <a:tc>
+                  <a:txBody>
+                    <a:bodyPr wrap="square"/>
+                    <a:lstStyle/>
+                    <a:p>
+                      <a:pPr algn="r"/>
+                      <a:r>
+                        <a:rPr sz="1000">
+                          <a:solidFill>
+                            <a:srgbClr val="4D4D4D"/>
+                          </a:solidFill>
+                          <a:latin typeface="DM Sans"/>
+                        </a:rPr>
+                        <a:t>3.941</a:t>
+                      </a:r>
+                    </a:p>
+                  </a:txBody>
+                  <a:tcPr marL="45000" marR="45000" marT="15000" marB="15000" anchor="ctr">
+                    <a:solidFill>
+                      <a:srgbClr val="FFFFFF"/>
+                    </a:solidFill>
+                  </a:tcPr>
+                </a:tc>
+                <a:tc>
+                  <a:txBody>
+                    <a:bodyPr wrap="square"/>
+                    <a:lstStyle/>
+                    <a:p>
+                      <a:pPr algn="r"/>
+                      <a:r>
+                        <a:rPr sz="1000">
+                          <a:solidFill>
+                            <a:srgbClr val="4D4D4D"/>
+                          </a:solidFill>
+                          <a:latin typeface="DM Sans"/>
+                        </a:rPr>
+                        <a:t>75%</a:t>
+                      </a:r>
+                    </a:p>
+                  </a:txBody>
+                  <a:tcPr marL="45000" marR="45000" marT="15000" marB="15000" anchor="ctr">
+                    <a:solidFill>
+                      <a:srgbClr val="FFFFFF"/>
+                    </a:solidFill>
+                  </a:tcPr>
+                </a:tc>
+              </a:tr>
+              <a:tr h="330000">
+                <a:tc>
+                  <a:txBody>
+                    <a:bodyPr wrap="square"/>
+                    <a:lstStyle/>
+                    <a:p>
+                      <a:pPr algn="l"/>
+                      <a:r>
+                        <a:rPr sz="1000">
+                          <a:solidFill>
+                            <a:srgbClr val="4D4D4D"/>
+                          </a:solidFill>
+                          <a:latin typeface="DM Sans"/>
+                        </a:rPr>
+                        <a:t>Out</a:t>
+                      </a:r>
+                    </a:p>
+                  </a:txBody>
+                  <a:tcPr marL="45000" marR="45000" marT="15000" marB="15000" anchor="ctr">
+                    <a:solidFill>
+                      <a:srgbClr val="F3F5F8"/>
+                    </a:solidFill>
+                  </a:tcPr>
+                </a:tc>
+                <a:tc>
+                  <a:txBody>
+                    <a:bodyPr wrap="square"/>
+                    <a:lstStyle/>
+                    <a:p>
+                      <a:pPr algn="r"/>
+                      <a:r>
+                        <a:rPr sz="1000">
+                          <a:solidFill>
+                            <a:srgbClr val="4D4D4D"/>
+                          </a:solidFill>
+                          <a:latin typeface="DM Sans"/>
+                        </a:rPr>
+                        <a:t>4.369</a:t>
+                      </a:r>
+                    </a:p>
+                  </a:txBody>
+                  <a:tcPr marL="45000" marR="45000" marT="15000" marB="15000" anchor="ctr">
+                    <a:solidFill>
+                      <a:srgbClr val="F3F5F8"/>
+                    </a:solidFill>
+                  </a:tcPr>
+                </a:tc>
+                <a:tc>
+                  <a:txBody>
+                    <a:bodyPr wrap="square"/>
+                    <a:lstStyle/>
+                    <a:p>
+                      <a:pPr algn="r"/>
+                      <a:r>
+                        <a:rPr sz="1000">
+                          <a:solidFill>
+                            <a:srgbClr val="4D4D4D"/>
+                          </a:solidFill>
+                          <a:latin typeface="DM Sans"/>
+                        </a:rPr>
+                        <a:t>84%</a:t>
+                      </a:r>
+                    </a:p>
+                  </a:txBody>
+                  <a:tcPr marL="45000" marR="45000" marT="15000" marB="15000" anchor="ctr">
+                    <a:solidFill>
+                      <a:srgbClr val="F3F5F8"/>
+                    </a:solidFill>
+                  </a:tcPr>
+                </a:tc>
+              </a:tr>
+              <a:tr h="330000">
+                <a:tc>
+                  <a:txBody>
+                    <a:bodyPr wrap="square"/>
+                    <a:lstStyle/>
+                    <a:p>
+                      <a:pPr algn="l"/>
+                      <a:r>
+                        <a:rPr sz="1000">
+                          <a:solidFill>
+                            <a:srgbClr val="4D4D4D"/>
+                          </a:solidFill>
+                          <a:latin typeface="DM Sans"/>
+                        </a:rPr>
+                        <a:t>Nov</a:t>
+                      </a:r>
+                    </a:p>
+                  </a:txBody>
+                  <a:tcPr marL="45000" marR="45000" marT="15000" marB="15000" anchor="ctr">
+                    <a:solidFill>
+                      <a:srgbClr val="FFFFFF"/>
+                    </a:solidFill>
+                  </a:tcPr>
+                </a:tc>
+                <a:tc>
+                  <a:txBody>
+                    <a:bodyPr wrap="square"/>
+                    <a:lstStyle/>
+                    <a:p>
+                      <a:pPr algn="r"/>
+                      <a:r>
+                        <a:rPr sz="1000">
+                          <a:solidFill>
+                            <a:srgbClr val="4D4D4D"/>
+                          </a:solidFill>
+                          <a:latin typeface="DM Sans"/>
+                        </a:rPr>
+                        <a:t>4.798</a:t>
+                      </a:r>
+                    </a:p>
+                  </a:txBody>
+                  <a:tcPr marL="45000" marR="45000" marT="15000" marB="15000" anchor="ctr">
+                    <a:solidFill>
+                      <a:srgbClr val="FFFFFF"/>
+                    </a:solidFill>
+                  </a:tcPr>
+                </a:tc>
+                <a:tc>
+                  <a:txBody>
+                    <a:bodyPr wrap="square"/>
+                    <a:lstStyle/>
+                    <a:p>
+                      <a:pPr algn="r"/>
+                      <a:r>
+                        <a:rPr sz="1000">
+                          <a:solidFill>
+                            <a:srgbClr val="4D4D4D"/>
+                          </a:solidFill>
+                          <a:latin typeface="DM Sans"/>
+                        </a:rPr>
+                        <a:t>92%</a:t>
+                      </a:r>
+                    </a:p>
+                  </a:txBody>
+                  <a:tcPr marL="45000" marR="45000" marT="15000" marB="15000" anchor="ctr">
+                    <a:solidFill>
+                      <a:srgbClr val="FFFFFF"/>
+                    </a:solidFill>
+                  </a:tcPr>
+                </a:tc>
+              </a:tr>
+              <a:tr h="330000">
+                <a:tc>
+                  <a:txBody>
+                    <a:bodyPr wrap="square"/>
+                    <a:lstStyle/>
+                    <a:p>
+                      <a:pPr algn="l"/>
+                      <a:r>
+                        <a:rPr sz="1000">
+                          <a:solidFill>
+                            <a:srgbClr val="4D4D4D"/>
+                          </a:solidFill>
+                          <a:latin typeface="DM Sans"/>
+                        </a:rPr>
+                        <a:t>Dez</a:t>
+                      </a:r>
+                    </a:p>
+                  </a:txBody>
+                  <a:tcPr marL="45000" marR="45000" marT="15000" marB="15000" anchor="ctr">
+                    <a:solidFill>
+                      <a:srgbClr val="F3F5F8"/>
+                    </a:solidFill>
+                  </a:tcPr>
+                </a:tc>
+                <a:tc>
+                  <a:txBody>
+                    <a:bodyPr wrap="square"/>
+                    <a:lstStyle/>
+                    <a:p>
+                      <a:pPr algn="r"/>
+                      <a:r>
+                        <a:rPr sz="1000">
+                          <a:solidFill>
+                            <a:srgbClr val="4D4D4D"/>
+                          </a:solidFill>
+                          <a:latin typeface="DM Sans"/>
+                        </a:rPr>
+                        <a:t>5.227</a:t>
+                      </a:r>
+                    </a:p>
+                  </a:txBody>
+                  <a:tcPr marL="45000" marR="45000" marT="15000" marB="15000" anchor="ctr">
+                    <a:solidFill>
+                      <a:srgbClr val="F3F5F8"/>
+                    </a:solidFill>
+                  </a:tcPr>
+                </a:tc>
+                <a:tc>
+                  <a:txBody>
+                    <a:bodyPr wrap="square"/>
+                    <a:lstStyle/>
+                    <a:p>
+                      <a:pPr algn="r"/>
+                      <a:r>
+                        <a:rPr sz="1000">
+                          <a:solidFill>
+                            <a:srgbClr val="4D4D4D"/>
+                          </a:solidFill>
+                          <a:latin typeface="DM Sans"/>
+                        </a:rPr>
+                        <a:t>100%</a:t>
+                      </a:r>
+                    </a:p>
+                  </a:txBody>
+                  <a:tcPr marL="45000" marR="45000" marT="15000" marB="15000" anchor="ctr">
+                    <a:solidFill>
+                      <a:srgbClr val="F3F5F8"/>
+                    </a:solidFill>
+                  </a:tcPr>
+                </a:tc>
+              </a:tr>
+            </a:tbl>
+          </a:graphicData>
+        </a:graphic>
+      </p:graphicFrame>
+    </p:spTree>
   </p:cSld>
   <p:clrMapOvr>
     <a:masterClrMapping/>
@@ -31845,7 +34553,7 @@
                 </a:solidFill>
                 <a:latin typeface="DM Sans"/>
               </a:rPr>
-              <a:t>05  ·  OBRAS DCMD – RL / RT  ·  PN 2027</a:t>
+              <a:t>07  ·  OBRAS DCMD – RL / RT  ·  PN 2027</a:t>
             </a:r>
             <a:r>
               <a:rPr sz="900" b="0" i="0">
@@ -36873,7 +39581,7 @@
                 </a:solidFill>
                 <a:latin typeface="DM Sans"/>
               </a:rPr>
-              <a:t>06  ·  OBRAS DCMD – RL / RT  ·  PN 2027</a:t>
+              <a:t>08  ·  OBRAS DCMD – RL / RT  ·  PN 2027</a:t>
             </a:r>
             <a:r>
               <a:rPr lang="pt-BR" sz="1000" b="1">
@@ -37164,7 +39872,7 @@
                 </a:solidFill>
                 <a:latin typeface="DM Sans"/>
               </a:rPr>
-              <a:t>08  ·  OBRAS DCMD – RL / RT  ·  PN 2027</a:t>
+              <a:t>10  ·  OBRAS DCMD – RL / RT  ·  PN 2027</a:t>
             </a:r>
             <a:r>
               <a:rPr lang="pt-BR" sz="1000" b="1">
@@ -37210,8 +39918,8 @@
         </p:nvSpPr>
         <p:spPr>
           <a:xfrm>
-            <a:off x="4007200" y="1330000"/>
-            <a:ext cx="894067" cy="300000"/>
+            <a:off x="4457200" y="1330000"/>
+            <a:ext cx="842001" cy="300000"/>
           </a:xfrm>
           <a:prstGeom prst="rect">
             <a:avLst/>
@@ -37256,8 +39964,8 @@
         </p:nvSpPr>
         <p:spPr>
           <a:xfrm>
-            <a:off x="4007200" y="1330000"/>
-            <a:ext cx="894067" cy="300000"/>
+            <a:off x="4457200" y="1330000"/>
+            <a:ext cx="842001" cy="300000"/>
           </a:xfrm>
           <a:prstGeom prst="rect">
             <a:avLst/>
@@ -37291,8 +39999,8 @@
         </p:nvSpPr>
         <p:spPr>
           <a:xfrm>
-            <a:off x="4007200" y="1630000"/>
-            <a:ext cx="894067" cy="3705000"/>
+            <a:off x="4457200" y="1630000"/>
+            <a:ext cx="842001" cy="3705000"/>
           </a:xfrm>
           <a:prstGeom prst="rect">
             <a:avLst/>
@@ -37335,8 +40043,8 @@
         </p:nvSpPr>
         <p:spPr>
           <a:xfrm>
-            <a:off x="4901267" y="1330000"/>
-            <a:ext cx="989860" cy="300000"/>
+            <a:off x="5299201" y="1330000"/>
+            <a:ext cx="932215" cy="300000"/>
           </a:xfrm>
           <a:prstGeom prst="rect">
             <a:avLst/>
@@ -37381,8 +40089,8 @@
         </p:nvSpPr>
         <p:spPr>
           <a:xfrm>
-            <a:off x="4901267" y="1330000"/>
-            <a:ext cx="989860" cy="300000"/>
+            <a:off x="5299201" y="1330000"/>
+            <a:ext cx="932215" cy="300000"/>
           </a:xfrm>
           <a:prstGeom prst="rect">
             <a:avLst/>
@@ -37416,8 +40124,8 @@
         </p:nvSpPr>
         <p:spPr>
           <a:xfrm>
-            <a:off x="5891127" y="1330000"/>
-            <a:ext cx="957929" cy="300000"/>
+            <a:off x="6231416" y="1330000"/>
+            <a:ext cx="902144" cy="300000"/>
           </a:xfrm>
           <a:prstGeom prst="rect">
             <a:avLst/>
@@ -37462,8 +40170,8 @@
         </p:nvSpPr>
         <p:spPr>
           <a:xfrm>
-            <a:off x="5891127" y="1330000"/>
-            <a:ext cx="957929" cy="300000"/>
+            <a:off x="6231416" y="1330000"/>
+            <a:ext cx="902144" cy="300000"/>
           </a:xfrm>
           <a:prstGeom prst="rect">
             <a:avLst/>
@@ -37497,8 +40205,8 @@
         </p:nvSpPr>
         <p:spPr>
           <a:xfrm>
-            <a:off x="5891127" y="1630000"/>
-            <a:ext cx="957929" cy="3705000"/>
+            <a:off x="6231416" y="1630000"/>
+            <a:ext cx="902144" cy="3705000"/>
           </a:xfrm>
           <a:prstGeom prst="rect">
             <a:avLst/>
@@ -37541,8 +40249,8 @@
         </p:nvSpPr>
         <p:spPr>
           <a:xfrm>
-            <a:off x="6849056" y="1330000"/>
-            <a:ext cx="989860" cy="300000"/>
+            <a:off x="7133560" y="1330000"/>
+            <a:ext cx="932215" cy="300000"/>
           </a:xfrm>
           <a:prstGeom prst="rect">
             <a:avLst/>
@@ -37587,8 +40295,8 @@
         </p:nvSpPr>
         <p:spPr>
           <a:xfrm>
-            <a:off x="6849056" y="1330000"/>
-            <a:ext cx="989860" cy="300000"/>
+            <a:off x="7133560" y="1330000"/>
+            <a:ext cx="932215" cy="300000"/>
           </a:xfrm>
           <a:prstGeom prst="rect">
             <a:avLst/>
@@ -37622,8 +40330,8 @@
         </p:nvSpPr>
         <p:spPr>
           <a:xfrm>
-            <a:off x="7838916" y="1330000"/>
-            <a:ext cx="957929" cy="300000"/>
+            <a:off x="8065776" y="1330000"/>
+            <a:ext cx="902144" cy="300000"/>
           </a:xfrm>
           <a:prstGeom prst="rect">
             <a:avLst/>
@@ -37668,8 +40376,8 @@
         </p:nvSpPr>
         <p:spPr>
           <a:xfrm>
-            <a:off x="7838916" y="1330000"/>
-            <a:ext cx="957929" cy="300000"/>
+            <a:off x="8065776" y="1330000"/>
+            <a:ext cx="902144" cy="300000"/>
           </a:xfrm>
           <a:prstGeom prst="rect">
             <a:avLst/>
@@ -37703,8 +40411,8 @@
         </p:nvSpPr>
         <p:spPr>
           <a:xfrm>
-            <a:off x="7838916" y="1630000"/>
-            <a:ext cx="957929" cy="3705000"/>
+            <a:off x="8065776" y="1630000"/>
+            <a:ext cx="902144" cy="3705000"/>
           </a:xfrm>
           <a:prstGeom prst="rect">
             <a:avLst/>
@@ -37747,8 +40455,8 @@
         </p:nvSpPr>
         <p:spPr>
           <a:xfrm>
-            <a:off x="8796845" y="1330000"/>
-            <a:ext cx="989860" cy="300000"/>
+            <a:off x="8967920" y="1330000"/>
+            <a:ext cx="932215" cy="300000"/>
           </a:xfrm>
           <a:prstGeom prst="rect">
             <a:avLst/>
@@ -37793,8 +40501,8 @@
         </p:nvSpPr>
         <p:spPr>
           <a:xfrm>
-            <a:off x="8796845" y="1330000"/>
-            <a:ext cx="989860" cy="300000"/>
+            <a:off x="8967920" y="1330000"/>
+            <a:ext cx="932215" cy="300000"/>
           </a:xfrm>
           <a:prstGeom prst="rect">
             <a:avLst/>
@@ -37828,8 +40536,8 @@
         </p:nvSpPr>
         <p:spPr>
           <a:xfrm>
-            <a:off x="9786705" y="1330000"/>
-            <a:ext cx="989860" cy="300000"/>
+            <a:off x="9900135" y="1330000"/>
+            <a:ext cx="932215" cy="300000"/>
           </a:xfrm>
           <a:prstGeom prst="rect">
             <a:avLst/>
@@ -37874,8 +40582,8 @@
         </p:nvSpPr>
         <p:spPr>
           <a:xfrm>
-            <a:off x="9786705" y="1330000"/>
-            <a:ext cx="989860" cy="300000"/>
+            <a:off x="9900135" y="1330000"/>
+            <a:ext cx="932215" cy="300000"/>
           </a:xfrm>
           <a:prstGeom prst="rect">
             <a:avLst/>
@@ -37909,8 +40617,8 @@
         </p:nvSpPr>
         <p:spPr>
           <a:xfrm>
-            <a:off x="9786705" y="1630000"/>
-            <a:ext cx="989860" cy="3705000"/>
+            <a:off x="9900135" y="1630000"/>
+            <a:ext cx="932215" cy="3705000"/>
           </a:xfrm>
           <a:prstGeom prst="rect">
             <a:avLst/>
@@ -37953,8 +40661,8 @@
         </p:nvSpPr>
         <p:spPr>
           <a:xfrm>
-            <a:off x="10776565" y="1330000"/>
-            <a:ext cx="957929" cy="300000"/>
+            <a:off x="10832350" y="1330000"/>
+            <a:ext cx="902144" cy="300000"/>
           </a:xfrm>
           <a:prstGeom prst="rect">
             <a:avLst/>
@@ -37999,8 +40707,8 @@
         </p:nvSpPr>
         <p:spPr>
           <a:xfrm>
-            <a:off x="10776565" y="1330000"/>
-            <a:ext cx="957929" cy="300000"/>
+            <a:off x="10832350" y="1330000"/>
+            <a:ext cx="902144" cy="300000"/>
           </a:xfrm>
           <a:prstGeom prst="rect">
             <a:avLst/>
@@ -38160,7 +40868,7 @@
         <p:spPr>
           <a:xfrm>
             <a:off x="457200" y="1630000"/>
-            <a:ext cx="3550000" cy="285000"/>
+            <a:ext cx="4000000" cy="285000"/>
           </a:xfrm>
           <a:prstGeom prst="rect">
             <a:avLst/>
@@ -38194,8 +40902,8 @@
         </p:nvSpPr>
         <p:spPr>
           <a:xfrm>
-            <a:off x="4486164" y="1690000"/>
-            <a:ext cx="957929" cy="165000"/>
+            <a:off x="4908272" y="1690000"/>
+            <a:ext cx="902144" cy="165000"/>
           </a:xfrm>
           <a:prstGeom prst="rect">
             <a:avLst/>
@@ -38238,8 +40946,8 @@
         </p:nvSpPr>
         <p:spPr>
           <a:xfrm>
-            <a:off x="5444093" y="1690000"/>
-            <a:ext cx="798274" cy="165000"/>
+            <a:off x="5810416" y="1690000"/>
+            <a:ext cx="751786" cy="165000"/>
           </a:xfrm>
           <a:prstGeom prst="rect">
             <a:avLst/>
@@ -38282,8 +40990,8 @@
         </p:nvSpPr>
         <p:spPr>
           <a:xfrm>
-            <a:off x="6242367" y="1690000"/>
-            <a:ext cx="478964" cy="165000"/>
+            <a:off x="6562202" y="1690000"/>
+            <a:ext cx="451072" cy="165000"/>
           </a:xfrm>
           <a:prstGeom prst="rect">
             <a:avLst/>
@@ -38326,8 +41034,8 @@
         </p:nvSpPr>
         <p:spPr>
           <a:xfrm>
-            <a:off x="6721332" y="1690000"/>
-            <a:ext cx="447033" cy="165000"/>
+            <a:off x="7013274" y="1690000"/>
+            <a:ext cx="421000" cy="165000"/>
           </a:xfrm>
           <a:prstGeom prst="rect">
             <a:avLst/>
@@ -38370,7 +41078,7 @@
         </p:nvSpPr>
         <p:spPr>
           <a:xfrm>
-            <a:off x="6651332" y="1702500"/>
+            <a:off x="6943274" y="1702500"/>
             <a:ext cx="140000" cy="140000"/>
           </a:xfrm>
           <a:prstGeom prst="diamond">
@@ -38416,7 +41124,7 @@
         </p:nvSpPr>
         <p:spPr>
           <a:xfrm>
-            <a:off x="7208366" y="1630000"/>
+            <a:off x="7474275" y="1630000"/>
             <a:ext cx="1000000" cy="285000"/>
           </a:xfrm>
           <a:prstGeom prst="rect">
@@ -38452,7 +41160,7 @@
         <p:spPr>
           <a:xfrm>
             <a:off x="457200" y="1915000"/>
-            <a:ext cx="3550000" cy="285000"/>
+            <a:ext cx="4000000" cy="285000"/>
           </a:xfrm>
           <a:prstGeom prst="rect">
             <a:avLst/>
@@ -38486,8 +41194,8 @@
         </p:nvSpPr>
         <p:spPr>
           <a:xfrm>
-            <a:off x="4486164" y="1975000"/>
-            <a:ext cx="957929" cy="165000"/>
+            <a:off x="4908272" y="1975000"/>
+            <a:ext cx="902144" cy="165000"/>
           </a:xfrm>
           <a:prstGeom prst="rect">
             <a:avLst/>
@@ -38530,8 +41238,8 @@
         </p:nvSpPr>
         <p:spPr>
           <a:xfrm>
-            <a:off x="5444093" y="1975000"/>
-            <a:ext cx="798274" cy="165000"/>
+            <a:off x="5810416" y="1975000"/>
+            <a:ext cx="751786" cy="165000"/>
           </a:xfrm>
           <a:prstGeom prst="rect">
             <a:avLst/>
@@ -38574,8 +41282,8 @@
         </p:nvSpPr>
         <p:spPr>
           <a:xfrm>
-            <a:off x="6242367" y="1975000"/>
-            <a:ext cx="478964" cy="165000"/>
+            <a:off x="6562202" y="1975000"/>
+            <a:ext cx="451072" cy="165000"/>
           </a:xfrm>
           <a:prstGeom prst="rect">
             <a:avLst/>
@@ -38618,8 +41326,8 @@
         </p:nvSpPr>
         <p:spPr>
           <a:xfrm>
-            <a:off x="6721332" y="1975000"/>
-            <a:ext cx="447033" cy="165000"/>
+            <a:off x="7013274" y="1975000"/>
+            <a:ext cx="421000" cy="165000"/>
           </a:xfrm>
           <a:prstGeom prst="rect">
             <a:avLst/>
@@ -38662,7 +41370,7 @@
         </p:nvSpPr>
         <p:spPr>
           <a:xfrm>
-            <a:off x="6651332" y="1987500"/>
+            <a:off x="6943274" y="1987500"/>
             <a:ext cx="140000" cy="140000"/>
           </a:xfrm>
           <a:prstGeom prst="diamond">
@@ -38708,7 +41416,7 @@
         </p:nvSpPr>
         <p:spPr>
           <a:xfrm>
-            <a:off x="7208366" y="1915000"/>
+            <a:off x="7474275" y="1915000"/>
             <a:ext cx="1000000" cy="285000"/>
           </a:xfrm>
           <a:prstGeom prst="rect">
@@ -38744,7 +41452,7 @@
         <p:spPr>
           <a:xfrm>
             <a:off x="457200" y="2200000"/>
-            <a:ext cx="3550000" cy="285000"/>
+            <a:ext cx="4000000" cy="285000"/>
           </a:xfrm>
           <a:prstGeom prst="rect">
             <a:avLst/>
@@ -38778,8 +41486,8 @@
         </p:nvSpPr>
         <p:spPr>
           <a:xfrm>
-            <a:off x="5380231" y="2260000"/>
-            <a:ext cx="957929" cy="165000"/>
+            <a:off x="5750273" y="2260000"/>
+            <a:ext cx="902144" cy="165000"/>
           </a:xfrm>
           <a:prstGeom prst="rect">
             <a:avLst/>
@@ -38822,8 +41530,8 @@
         </p:nvSpPr>
         <p:spPr>
           <a:xfrm>
-            <a:off x="6338160" y="2260000"/>
-            <a:ext cx="798274" cy="165000"/>
+            <a:off x="6652417" y="2260000"/>
+            <a:ext cx="751786" cy="165000"/>
           </a:xfrm>
           <a:prstGeom prst="rect">
             <a:avLst/>
@@ -38866,8 +41574,8 @@
         </p:nvSpPr>
         <p:spPr>
           <a:xfrm>
-            <a:off x="7136435" y="2260000"/>
-            <a:ext cx="478964" cy="165000"/>
+            <a:off x="7404203" y="2260000"/>
+            <a:ext cx="451072" cy="165000"/>
           </a:xfrm>
           <a:prstGeom prst="rect">
             <a:avLst/>
@@ -38910,8 +41618,8 @@
         </p:nvSpPr>
         <p:spPr>
           <a:xfrm>
-            <a:off x="7615399" y="2260000"/>
-            <a:ext cx="447033" cy="165000"/>
+            <a:off x="7855275" y="2260000"/>
+            <a:ext cx="421000" cy="165000"/>
           </a:xfrm>
           <a:prstGeom prst="rect">
             <a:avLst/>
@@ -38954,7 +41662,7 @@
         </p:nvSpPr>
         <p:spPr>
           <a:xfrm>
-            <a:off x="7545399" y="2272500"/>
+            <a:off x="7785275" y="2272500"/>
             <a:ext cx="140000" cy="140000"/>
           </a:xfrm>
           <a:prstGeom prst="diamond">
@@ -39000,7 +41708,7 @@
         </p:nvSpPr>
         <p:spPr>
           <a:xfrm>
-            <a:off x="8102433" y="2200000"/>
+            <a:off x="8316276" y="2200000"/>
             <a:ext cx="1000000" cy="285000"/>
           </a:xfrm>
           <a:prstGeom prst="rect">
@@ -39036,7 +41744,7 @@
         <p:spPr>
           <a:xfrm>
             <a:off x="457200" y="2485000"/>
-            <a:ext cx="3550000" cy="285000"/>
+            <a:ext cx="4000000" cy="285000"/>
           </a:xfrm>
           <a:prstGeom prst="rect">
             <a:avLst/>
@@ -39070,8 +41778,8 @@
         </p:nvSpPr>
         <p:spPr>
           <a:xfrm>
-            <a:off x="5380231" y="2545000"/>
-            <a:ext cx="957929" cy="165000"/>
+            <a:off x="5750273" y="2545000"/>
+            <a:ext cx="902144" cy="165000"/>
           </a:xfrm>
           <a:prstGeom prst="rect">
             <a:avLst/>
@@ -39114,8 +41822,8 @@
         </p:nvSpPr>
         <p:spPr>
           <a:xfrm>
-            <a:off x="6338160" y="2545000"/>
-            <a:ext cx="798274" cy="165000"/>
+            <a:off x="6652417" y="2545000"/>
+            <a:ext cx="751786" cy="165000"/>
           </a:xfrm>
           <a:prstGeom prst="rect">
             <a:avLst/>
@@ -39158,8 +41866,8 @@
         </p:nvSpPr>
         <p:spPr>
           <a:xfrm>
-            <a:off x="7136435" y="2545000"/>
-            <a:ext cx="478964" cy="165000"/>
+            <a:off x="7404203" y="2545000"/>
+            <a:ext cx="451072" cy="165000"/>
           </a:xfrm>
           <a:prstGeom prst="rect">
             <a:avLst/>
@@ -39202,8 +41910,8 @@
         </p:nvSpPr>
         <p:spPr>
           <a:xfrm>
-            <a:off x="7615399" y="2545000"/>
-            <a:ext cx="447033" cy="165000"/>
+            <a:off x="7855275" y="2545000"/>
+            <a:ext cx="421000" cy="165000"/>
           </a:xfrm>
           <a:prstGeom prst="rect">
             <a:avLst/>
@@ -39246,7 +41954,7 @@
         </p:nvSpPr>
         <p:spPr>
           <a:xfrm>
-            <a:off x="7545399" y="2557500"/>
+            <a:off x="7785275" y="2557500"/>
             <a:ext cx="140000" cy="140000"/>
           </a:xfrm>
           <a:prstGeom prst="diamond">
@@ -39292,7 +42000,7 @@
         </p:nvSpPr>
         <p:spPr>
           <a:xfrm>
-            <a:off x="8102433" y="2485000"/>
+            <a:off x="8316276" y="2485000"/>
             <a:ext cx="1000000" cy="285000"/>
           </a:xfrm>
           <a:prstGeom prst="rect">
@@ -39328,7 +42036,7 @@
         <p:spPr>
           <a:xfrm>
             <a:off x="457200" y="2770000"/>
-            <a:ext cx="3550000" cy="285000"/>
+            <a:ext cx="4000000" cy="285000"/>
           </a:xfrm>
           <a:prstGeom prst="rect">
             <a:avLst/>
@@ -39362,8 +42070,8 @@
         </p:nvSpPr>
         <p:spPr>
           <a:xfrm>
-            <a:off x="5380231" y="2830000"/>
-            <a:ext cx="957929" cy="165000"/>
+            <a:off x="5750273" y="2830000"/>
+            <a:ext cx="902144" cy="165000"/>
           </a:xfrm>
           <a:prstGeom prst="rect">
             <a:avLst/>
@@ -39406,8 +42114,8 @@
         </p:nvSpPr>
         <p:spPr>
           <a:xfrm>
-            <a:off x="6338160" y="2830000"/>
-            <a:ext cx="798274" cy="165000"/>
+            <a:off x="6652417" y="2830000"/>
+            <a:ext cx="751786" cy="165000"/>
           </a:xfrm>
           <a:prstGeom prst="rect">
             <a:avLst/>
@@ -39450,8 +42158,8 @@
         </p:nvSpPr>
         <p:spPr>
           <a:xfrm>
-            <a:off x="7136435" y="2830000"/>
-            <a:ext cx="478964" cy="165000"/>
+            <a:off x="7404203" y="2830000"/>
+            <a:ext cx="451072" cy="165000"/>
           </a:xfrm>
           <a:prstGeom prst="rect">
             <a:avLst/>
@@ -39494,8 +42202,8 @@
         </p:nvSpPr>
         <p:spPr>
           <a:xfrm>
-            <a:off x="7615399" y="2830000"/>
-            <a:ext cx="447033" cy="165000"/>
+            <a:off x="7855275" y="2830000"/>
+            <a:ext cx="421000" cy="165000"/>
           </a:xfrm>
           <a:prstGeom prst="rect">
             <a:avLst/>
@@ -39538,7 +42246,7 @@
         </p:nvSpPr>
         <p:spPr>
           <a:xfrm>
-            <a:off x="7545399" y="2842500"/>
+            <a:off x="7785275" y="2842500"/>
             <a:ext cx="140000" cy="140000"/>
           </a:xfrm>
           <a:prstGeom prst="diamond">
@@ -39584,7 +42292,7 @@
         </p:nvSpPr>
         <p:spPr>
           <a:xfrm>
-            <a:off x="8102433" y="2770000"/>
+            <a:off x="8316276" y="2770000"/>
             <a:ext cx="1000000" cy="285000"/>
           </a:xfrm>
           <a:prstGeom prst="rect">
@@ -39620,7 +42328,7 @@
         <p:spPr>
           <a:xfrm>
             <a:off x="457200" y="3055000"/>
-            <a:ext cx="3550000" cy="285000"/>
+            <a:ext cx="4000000" cy="285000"/>
           </a:xfrm>
           <a:prstGeom prst="rect">
             <a:avLst/>
@@ -39641,7 +42349,7 @@
                 </a:solidFill>
                 <a:latin typeface="DM Sans"/>
               </a:rPr>
-              <a:t>B6 · 70838 · RT ×1 · LD Cristalândia - Lagoa da Confusã</a:t>
+              <a:t>B6 · 70838 · RT ×1 · LD Cristalândia - Lagoa da Confusão</a:t>
             </a:r>
           </a:p>
         </p:txBody>
@@ -39654,8 +42362,8 @@
         </p:nvSpPr>
         <p:spPr>
           <a:xfrm>
-            <a:off x="6497815" y="3115000"/>
-            <a:ext cx="957929" cy="165000"/>
+            <a:off x="6802774" y="3115000"/>
+            <a:ext cx="902144" cy="165000"/>
           </a:xfrm>
           <a:prstGeom prst="rect">
             <a:avLst/>
@@ -39698,8 +42406,8 @@
         </p:nvSpPr>
         <p:spPr>
           <a:xfrm>
-            <a:off x="7455744" y="3115000"/>
-            <a:ext cx="798274" cy="165000"/>
+            <a:off x="7704918" y="3115000"/>
+            <a:ext cx="751786" cy="165000"/>
           </a:xfrm>
           <a:prstGeom prst="rect">
             <a:avLst/>
@@ -39742,8 +42450,8 @@
         </p:nvSpPr>
         <p:spPr>
           <a:xfrm>
-            <a:off x="8254019" y="3115000"/>
-            <a:ext cx="478964" cy="165000"/>
+            <a:off x="8456705" y="3115000"/>
+            <a:ext cx="451072" cy="165000"/>
           </a:xfrm>
           <a:prstGeom prst="rect">
             <a:avLst/>
@@ -39786,8 +42494,8 @@
         </p:nvSpPr>
         <p:spPr>
           <a:xfrm>
-            <a:off x="8732983" y="3115000"/>
-            <a:ext cx="447033" cy="165000"/>
+            <a:off x="8907777" y="3115000"/>
+            <a:ext cx="421000" cy="165000"/>
           </a:xfrm>
           <a:prstGeom prst="rect">
             <a:avLst/>
@@ -39830,7 +42538,7 @@
         </p:nvSpPr>
         <p:spPr>
           <a:xfrm>
-            <a:off x="8662983" y="3127500"/>
+            <a:off x="8837777" y="3127500"/>
             <a:ext cx="140000" cy="140000"/>
           </a:xfrm>
           <a:prstGeom prst="diamond">
@@ -39876,7 +42584,7 @@
         </p:nvSpPr>
         <p:spPr>
           <a:xfrm>
-            <a:off x="9220017" y="3055000"/>
+            <a:off x="9368777" y="3055000"/>
             <a:ext cx="1000000" cy="285000"/>
           </a:xfrm>
           <a:prstGeom prst="rect">
@@ -39912,7 +42620,7 @@
         <p:spPr>
           <a:xfrm>
             <a:off x="457200" y="3340000"/>
-            <a:ext cx="3550000" cy="285000"/>
+            <a:ext cx="4000000" cy="285000"/>
           </a:xfrm>
           <a:prstGeom prst="rect">
             <a:avLst/>
@@ -39946,8 +42654,8 @@
         </p:nvSpPr>
         <p:spPr>
           <a:xfrm>
-            <a:off x="6497815" y="3400000"/>
-            <a:ext cx="957929" cy="165000"/>
+            <a:off x="6802774" y="3400000"/>
+            <a:ext cx="902144" cy="165000"/>
           </a:xfrm>
           <a:prstGeom prst="rect">
             <a:avLst/>
@@ -39990,8 +42698,8 @@
         </p:nvSpPr>
         <p:spPr>
           <a:xfrm>
-            <a:off x="7455744" y="3400000"/>
-            <a:ext cx="798274" cy="165000"/>
+            <a:off x="7704918" y="3400000"/>
+            <a:ext cx="751786" cy="165000"/>
           </a:xfrm>
           <a:prstGeom prst="rect">
             <a:avLst/>
@@ -40034,8 +42742,8 @@
         </p:nvSpPr>
         <p:spPr>
           <a:xfrm>
-            <a:off x="8254019" y="3400000"/>
-            <a:ext cx="478964" cy="165000"/>
+            <a:off x="8456705" y="3400000"/>
+            <a:ext cx="451072" cy="165000"/>
           </a:xfrm>
           <a:prstGeom prst="rect">
             <a:avLst/>
@@ -40078,8 +42786,8 @@
         </p:nvSpPr>
         <p:spPr>
           <a:xfrm>
-            <a:off x="8732983" y="3400000"/>
-            <a:ext cx="447033" cy="165000"/>
+            <a:off x="8907777" y="3400000"/>
+            <a:ext cx="421000" cy="165000"/>
           </a:xfrm>
           <a:prstGeom prst="rect">
             <a:avLst/>
@@ -40122,7 +42830,7 @@
         </p:nvSpPr>
         <p:spPr>
           <a:xfrm>
-            <a:off x="8662983" y="3412500"/>
+            <a:off x="8837777" y="3412500"/>
             <a:ext cx="140000" cy="140000"/>
           </a:xfrm>
           <a:prstGeom prst="diamond">
@@ -40168,7 +42876,7 @@
         </p:nvSpPr>
         <p:spPr>
           <a:xfrm>
-            <a:off x="9220017" y="3340000"/>
+            <a:off x="9368777" y="3340000"/>
             <a:ext cx="1000000" cy="285000"/>
           </a:xfrm>
           <a:prstGeom prst="rect">
@@ -40204,7 +42912,7 @@
         <p:spPr>
           <a:xfrm>
             <a:off x="457200" y="3625000"/>
-            <a:ext cx="3550000" cy="285000"/>
+            <a:ext cx="4000000" cy="285000"/>
           </a:xfrm>
           <a:prstGeom prst="rect">
             <a:avLst/>
@@ -40225,7 +42933,7 @@
                 </a:solidFill>
                 <a:latin typeface="DM Sans"/>
               </a:rPr>
-              <a:t>B8 · 92094 · RL ×3 · QS-LD Palmas - Aparecida do Rio Ne</a:t>
+              <a:t>B8 · 92094 · RL ×3 · QS-LD Palmas - Aparecida do Rio Negro</a:t>
             </a:r>
           </a:p>
         </p:txBody>
@@ -40238,8 +42946,8 @@
         </p:nvSpPr>
         <p:spPr>
           <a:xfrm>
-            <a:off x="6497815" y="3685000"/>
-            <a:ext cx="957929" cy="165000"/>
+            <a:off x="6802774" y="3685000"/>
+            <a:ext cx="902144" cy="165000"/>
           </a:xfrm>
           <a:prstGeom prst="rect">
             <a:avLst/>
@@ -40282,8 +42990,8 @@
         </p:nvSpPr>
         <p:spPr>
           <a:xfrm>
-            <a:off x="7455744" y="3685000"/>
-            <a:ext cx="798274" cy="165000"/>
+            <a:off x="7704918" y="3685000"/>
+            <a:ext cx="751786" cy="165000"/>
           </a:xfrm>
           <a:prstGeom prst="rect">
             <a:avLst/>
@@ -40326,8 +43034,8 @@
         </p:nvSpPr>
         <p:spPr>
           <a:xfrm>
-            <a:off x="8254019" y="3685000"/>
-            <a:ext cx="478964" cy="165000"/>
+            <a:off x="8456705" y="3685000"/>
+            <a:ext cx="451072" cy="165000"/>
           </a:xfrm>
           <a:prstGeom prst="rect">
             <a:avLst/>
@@ -40370,8 +43078,8 @@
         </p:nvSpPr>
         <p:spPr>
           <a:xfrm>
-            <a:off x="8732983" y="3685000"/>
-            <a:ext cx="447033" cy="165000"/>
+            <a:off x="8907777" y="3685000"/>
+            <a:ext cx="421000" cy="165000"/>
           </a:xfrm>
           <a:prstGeom prst="rect">
             <a:avLst/>
@@ -40414,7 +43122,7 @@
         </p:nvSpPr>
         <p:spPr>
           <a:xfrm>
-            <a:off x="8662983" y="3697500"/>
+            <a:off x="8837777" y="3697500"/>
             <a:ext cx="140000" cy="140000"/>
           </a:xfrm>
           <a:prstGeom prst="diamond">
@@ -40460,7 +43168,7 @@
         </p:nvSpPr>
         <p:spPr>
           <a:xfrm>
-            <a:off x="9220017" y="3625000"/>
+            <a:off x="9368777" y="3625000"/>
             <a:ext cx="1000000" cy="285000"/>
           </a:xfrm>
           <a:prstGeom prst="rect">
@@ -40496,7 +43204,7 @@
         <p:spPr>
           <a:xfrm>
             <a:off x="457200" y="3910000"/>
-            <a:ext cx="3550000" cy="285000"/>
+            <a:ext cx="4000000" cy="285000"/>
           </a:xfrm>
           <a:prstGeom prst="rect">
             <a:avLst/>
@@ -40530,8 +43238,8 @@
         </p:nvSpPr>
         <p:spPr>
           <a:xfrm>
-            <a:off x="6497815" y="3970000"/>
-            <a:ext cx="957929" cy="165000"/>
+            <a:off x="6802774" y="3970000"/>
+            <a:ext cx="902144" cy="165000"/>
           </a:xfrm>
           <a:prstGeom prst="rect">
             <a:avLst/>
@@ -40574,8 +43282,8 @@
         </p:nvSpPr>
         <p:spPr>
           <a:xfrm>
-            <a:off x="7455744" y="3970000"/>
-            <a:ext cx="798274" cy="165000"/>
+            <a:off x="7704918" y="3970000"/>
+            <a:ext cx="751786" cy="165000"/>
           </a:xfrm>
           <a:prstGeom prst="rect">
             <a:avLst/>
@@ -40618,8 +43326,8 @@
         </p:nvSpPr>
         <p:spPr>
           <a:xfrm>
-            <a:off x="8254019" y="3970000"/>
-            <a:ext cx="478964" cy="165000"/>
+            <a:off x="8456705" y="3970000"/>
+            <a:ext cx="451072" cy="165000"/>
           </a:xfrm>
           <a:prstGeom prst="rect">
             <a:avLst/>
@@ -40662,8 +43370,8 @@
         </p:nvSpPr>
         <p:spPr>
           <a:xfrm>
-            <a:off x="8732983" y="3970000"/>
-            <a:ext cx="447033" cy="165000"/>
+            <a:off x="8907777" y="3970000"/>
+            <a:ext cx="421000" cy="165000"/>
           </a:xfrm>
           <a:prstGeom prst="rect">
             <a:avLst/>
@@ -40706,7 +43414,7 @@
         </p:nvSpPr>
         <p:spPr>
           <a:xfrm>
-            <a:off x="8662983" y="3982500"/>
+            <a:off x="8837777" y="3982500"/>
             <a:ext cx="140000" cy="140000"/>
           </a:xfrm>
           <a:prstGeom prst="diamond">
@@ -40752,7 +43460,7 @@
         </p:nvSpPr>
         <p:spPr>
           <a:xfrm>
-            <a:off x="9220017" y="3910000"/>
+            <a:off x="9368777" y="3910000"/>
             <a:ext cx="1000000" cy="285000"/>
           </a:xfrm>
           <a:prstGeom prst="rect">
@@ -40788,7 +43496,7 @@
         <p:spPr>
           <a:xfrm>
             <a:off x="457200" y="4195000"/>
-            <a:ext cx="3550000" cy="285000"/>
+            <a:ext cx="4000000" cy="285000"/>
           </a:xfrm>
           <a:prstGeom prst="rect">
             <a:avLst/>
@@ -40822,8 +43530,8 @@
         </p:nvSpPr>
         <p:spPr>
           <a:xfrm>
-            <a:off x="6497815" y="4255000"/>
-            <a:ext cx="957929" cy="165000"/>
+            <a:off x="6802774" y="4255000"/>
+            <a:ext cx="902144" cy="165000"/>
           </a:xfrm>
           <a:prstGeom prst="rect">
             <a:avLst/>
@@ -40866,8 +43574,8 @@
         </p:nvSpPr>
         <p:spPr>
           <a:xfrm>
-            <a:off x="7455744" y="4255000"/>
-            <a:ext cx="798274" cy="165000"/>
+            <a:off x="7704918" y="4255000"/>
+            <a:ext cx="751786" cy="165000"/>
           </a:xfrm>
           <a:prstGeom prst="rect">
             <a:avLst/>
@@ -40910,8 +43618,8 @@
         </p:nvSpPr>
         <p:spPr>
           <a:xfrm>
-            <a:off x="8254019" y="4255000"/>
-            <a:ext cx="478964" cy="165000"/>
+            <a:off x="8456705" y="4255000"/>
+            <a:ext cx="451072" cy="165000"/>
           </a:xfrm>
           <a:prstGeom prst="rect">
             <a:avLst/>
@@ -40954,8 +43662,8 @@
         </p:nvSpPr>
         <p:spPr>
           <a:xfrm>
-            <a:off x="8732983" y="4255000"/>
-            <a:ext cx="447033" cy="165000"/>
+            <a:off x="8907777" y="4255000"/>
+            <a:ext cx="421000" cy="165000"/>
           </a:xfrm>
           <a:prstGeom prst="rect">
             <a:avLst/>
@@ -40998,7 +43706,7 @@
         </p:nvSpPr>
         <p:spPr>
           <a:xfrm>
-            <a:off x="8662983" y="4267500"/>
+            <a:off x="8837777" y="4267500"/>
             <a:ext cx="140000" cy="140000"/>
           </a:xfrm>
           <a:prstGeom prst="diamond">
@@ -41044,7 +43752,7 @@
         </p:nvSpPr>
         <p:spPr>
           <a:xfrm>
-            <a:off x="9220017" y="4195000"/>
+            <a:off x="9368777" y="4195000"/>
             <a:ext cx="1000000" cy="285000"/>
           </a:xfrm>
           <a:prstGeom prst="rect">
@@ -41080,7 +43788,7 @@
         <p:spPr>
           <a:xfrm>
             <a:off x="457200" y="4480000"/>
-            <a:ext cx="3550000" cy="285000"/>
+            <a:ext cx="4000000" cy="285000"/>
           </a:xfrm>
           <a:prstGeom prst="rect">
             <a:avLst/>
@@ -41114,8 +43822,8 @@
         </p:nvSpPr>
         <p:spPr>
           <a:xfrm>
-            <a:off x="6497815" y="4540000"/>
-            <a:ext cx="957929" cy="165000"/>
+            <a:off x="6802774" y="4540000"/>
+            <a:ext cx="902144" cy="165000"/>
           </a:xfrm>
           <a:prstGeom prst="rect">
             <a:avLst/>
@@ -41158,8 +43866,8 @@
         </p:nvSpPr>
         <p:spPr>
           <a:xfrm>
-            <a:off x="7455744" y="4540000"/>
-            <a:ext cx="798274" cy="165000"/>
+            <a:off x="7704918" y="4540000"/>
+            <a:ext cx="751786" cy="165000"/>
           </a:xfrm>
           <a:prstGeom prst="rect">
             <a:avLst/>
@@ -41202,8 +43910,8 @@
         </p:nvSpPr>
         <p:spPr>
           <a:xfrm>
-            <a:off x="8254019" y="4540000"/>
-            <a:ext cx="478964" cy="165000"/>
+            <a:off x="8456705" y="4540000"/>
+            <a:ext cx="451072" cy="165000"/>
           </a:xfrm>
           <a:prstGeom prst="rect">
             <a:avLst/>
@@ -41246,8 +43954,8 @@
         </p:nvSpPr>
         <p:spPr>
           <a:xfrm>
-            <a:off x="8732983" y="4540000"/>
-            <a:ext cx="447033" cy="165000"/>
+            <a:off x="8907777" y="4540000"/>
+            <a:ext cx="421000" cy="165000"/>
           </a:xfrm>
           <a:prstGeom prst="rect">
             <a:avLst/>
@@ -41290,7 +43998,7 @@
         </p:nvSpPr>
         <p:spPr>
           <a:xfrm>
-            <a:off x="8662983" y="4552500"/>
+            <a:off x="8837777" y="4552500"/>
             <a:ext cx="140000" cy="140000"/>
           </a:xfrm>
           <a:prstGeom prst="diamond">
@@ -41336,7 +44044,7 @@
         </p:nvSpPr>
         <p:spPr>
           <a:xfrm>
-            <a:off x="9220017" y="4480000"/>
+            <a:off x="9368777" y="4480000"/>
             <a:ext cx="1000000" cy="285000"/>
           </a:xfrm>
           <a:prstGeom prst="rect">
@@ -41372,7 +44080,7 @@
         <p:spPr>
           <a:xfrm>
             <a:off x="457200" y="4765000"/>
-            <a:ext cx="3550000" cy="285000"/>
+            <a:ext cx="4000000" cy="285000"/>
           </a:xfrm>
           <a:prstGeom prst="rect">
             <a:avLst/>
@@ -41406,8 +44114,8 @@
         </p:nvSpPr>
         <p:spPr>
           <a:xfrm>
-            <a:off x="8509466" y="4825000"/>
-            <a:ext cx="957929" cy="165000"/>
+            <a:off x="8697276" y="4825000"/>
+            <a:ext cx="902144" cy="165000"/>
           </a:xfrm>
           <a:prstGeom prst="rect">
             <a:avLst/>
@@ -41450,8 +44158,8 @@
         </p:nvSpPr>
         <p:spPr>
           <a:xfrm>
-            <a:off x="9467396" y="4825000"/>
-            <a:ext cx="798274" cy="165000"/>
+            <a:off x="9599420" y="4825000"/>
+            <a:ext cx="751786" cy="165000"/>
           </a:xfrm>
           <a:prstGeom prst="rect">
             <a:avLst/>
@@ -41494,8 +44202,8 @@
         </p:nvSpPr>
         <p:spPr>
           <a:xfrm>
-            <a:off x="10265670" y="4825000"/>
-            <a:ext cx="478964" cy="165000"/>
+            <a:off x="10351207" y="4825000"/>
+            <a:ext cx="451072" cy="165000"/>
           </a:xfrm>
           <a:prstGeom prst="rect">
             <a:avLst/>
@@ -41538,8 +44246,8 @@
         </p:nvSpPr>
         <p:spPr>
           <a:xfrm>
-            <a:off x="10744634" y="4825000"/>
-            <a:ext cx="447033" cy="165000"/>
+            <a:off x="10802279" y="4825000"/>
+            <a:ext cx="421000" cy="165000"/>
           </a:xfrm>
           <a:prstGeom prst="rect">
             <a:avLst/>
@@ -41582,7 +44290,7 @@
         </p:nvSpPr>
         <p:spPr>
           <a:xfrm>
-            <a:off x="10674634" y="4837500"/>
+            <a:off x="10732279" y="4837500"/>
             <a:ext cx="140000" cy="140000"/>
           </a:xfrm>
           <a:prstGeom prst="diamond">
@@ -41628,7 +44336,7 @@
         </p:nvSpPr>
         <p:spPr>
           <a:xfrm>
-            <a:off x="11231668" y="4765000"/>
+            <a:off x="11263280" y="4765000"/>
             <a:ext cx="1000000" cy="285000"/>
           </a:xfrm>
           <a:prstGeom prst="rect">
@@ -41664,7 +44372,7 @@
         <p:spPr>
           <a:xfrm>
             <a:off x="457200" y="5050000"/>
-            <a:ext cx="3550000" cy="285000"/>
+            <a:ext cx="4000000" cy="285000"/>
           </a:xfrm>
           <a:prstGeom prst="rect">
             <a:avLst/>
@@ -41698,8 +44406,8 @@
         </p:nvSpPr>
         <p:spPr>
           <a:xfrm>
-            <a:off x="8509466" y="5110000"/>
-            <a:ext cx="957929" cy="165000"/>
+            <a:off x="8697276" y="5110000"/>
+            <a:ext cx="902144" cy="165000"/>
           </a:xfrm>
           <a:prstGeom prst="rect">
             <a:avLst/>
@@ -41742,8 +44450,8 @@
         </p:nvSpPr>
         <p:spPr>
           <a:xfrm>
-            <a:off x="9467396" y="5110000"/>
-            <a:ext cx="798274" cy="165000"/>
+            <a:off x="9599420" y="5110000"/>
+            <a:ext cx="751786" cy="165000"/>
           </a:xfrm>
           <a:prstGeom prst="rect">
             <a:avLst/>
@@ -41786,8 +44494,8 @@
         </p:nvSpPr>
         <p:spPr>
           <a:xfrm>
-            <a:off x="10265670" y="5110000"/>
-            <a:ext cx="478964" cy="165000"/>
+            <a:off x="10351207" y="5110000"/>
+            <a:ext cx="451072" cy="165000"/>
           </a:xfrm>
           <a:prstGeom prst="rect">
             <a:avLst/>
@@ -41830,8 +44538,8 @@
         </p:nvSpPr>
         <p:spPr>
           <a:xfrm>
-            <a:off x="10744634" y="5110000"/>
-            <a:ext cx="447033" cy="165000"/>
+            <a:off x="10802279" y="5110000"/>
+            <a:ext cx="421000" cy="165000"/>
           </a:xfrm>
           <a:prstGeom prst="rect">
             <a:avLst/>
@@ -41874,7 +44582,7 @@
         </p:nvSpPr>
         <p:spPr>
           <a:xfrm>
-            <a:off x="10674634" y="5122500"/>
+            <a:off x="10732279" y="5122500"/>
             <a:ext cx="140000" cy="140000"/>
           </a:xfrm>
           <a:prstGeom prst="diamond">
@@ -41920,7 +44628,7 @@
         </p:nvSpPr>
         <p:spPr>
           <a:xfrm>
-            <a:off x="11231668" y="5050000"/>
+            <a:off x="11263280" y="5050000"/>
             <a:ext cx="1000000" cy="285000"/>
           </a:xfrm>
           <a:prstGeom prst="rect">

</xml_diff>